<commit_message>
Improve presentation.pptx with better styling and placeholders
Co-authored-by: wuzhi456 <217564920+wuzhi456@users.noreply.github.com>
</commit_message>
<xml_diff>
--- a/presentation.pptx
+++ b/presentation.pptx
@@ -20,6 +20,7 @@
     <p:sldId id="268" r:id="rId19"/>
     <p:sldId id="269" r:id="rId20"/>
     <p:sldId id="270" r:id="rId21"/>
+    <p:sldId id="271" r:id="rId22"/>
   </p:sldIdLst>
   <p:sldSz cx="12191695" cy="6858000" type="screen4x3"/>
   <p:notesSz cx="6858000" cy="9144000"/>
@@ -3104,14 +3105,57 @@
       <p:grpSpPr/>
       <p:sp>
         <p:nvSpPr>
-          <p:cNvPr id="2" name="TextBox 1"/>
+          <p:cNvPr id="2" name="Rectangle 1"/>
+          <p:cNvSpPr/>
+          <p:nvPr/>
+        </p:nvSpPr>
+        <p:spPr>
+          <a:xfrm>
+            <a:off x="0" y="2286000"/>
+            <a:ext cx="12191695" cy="2286000"/>
+          </a:xfrm>
+          <a:prstGeom prst="rect">
+            <a:avLst/>
+          </a:prstGeom>
+          <a:solidFill>
+            <a:srgbClr val="003366"/>
+          </a:solidFill>
+          <a:ln>
+            <a:noFill/>
+          </a:ln>
+        </p:spPr>
+        <p:style>
+          <a:lnRef idx="1">
+            <a:schemeClr val="accent1"/>
+          </a:lnRef>
+          <a:fillRef idx="3">
+            <a:schemeClr val="accent1"/>
+          </a:fillRef>
+          <a:effectRef idx="2">
+            <a:schemeClr val="accent1"/>
+          </a:effectRef>
+          <a:fontRef idx="minor">
+            <a:schemeClr val="lt1"/>
+          </a:fontRef>
+        </p:style>
+        <p:txBody>
+          <a:bodyPr rtlCol="0" anchor="ctr"/>
+          <a:lstStyle/>
+          <a:p>
+            <a:pPr algn="ctr"/>
+          </a:p>
+        </p:txBody>
+      </p:sp>
+      <p:sp>
+        <p:nvSpPr>
+          <p:cNvPr id="3" name="TextBox 2"/>
           <p:cNvSpPr txBox="1"/>
           <p:nvPr/>
         </p:nvSpPr>
         <p:spPr>
           <a:xfrm>
-            <a:off x="457200" y="274320"/>
-            <a:ext cx="11277295" cy="731520"/>
+            <a:off x="457200" y="2560320"/>
+            <a:ext cx="11277295" cy="1097280"/>
           </a:xfrm>
           <a:prstGeom prst="rect">
             <a:avLst/>
@@ -3124,8 +3168,12 @@
           </a:bodyPr>
           <a:lstStyle/>
           <a:p>
-            <a:pPr>
-              <a:defRPr sz="3200" b="1"/>
+            <a:pPr algn="ctr">
+              <a:defRPr sz="4800" b="1">
+                <a:solidFill>
+                  <a:srgbClr val="FFFFFF"/>
+                </a:solidFill>
+              </a:defRPr>
             </a:pPr>
             <a:r>
               <a:t>CS305 P2P File Transfer System</a:t>
@@ -3135,14 +3183,14 @@
       </p:sp>
       <p:sp>
         <p:nvSpPr>
-          <p:cNvPr id="3" name="TextBox 2"/>
+          <p:cNvPr id="4" name="TextBox 3"/>
           <p:cNvSpPr txBox="1"/>
           <p:nvPr/>
         </p:nvSpPr>
         <p:spPr>
           <a:xfrm>
-            <a:off x="457200" y="1188720"/>
-            <a:ext cx="11277295" cy="5212080"/>
+            <a:off x="457200" y="3749039"/>
+            <a:ext cx="11277295" cy="731520"/>
           </a:xfrm>
           <a:prstGeom prst="rect">
             <a:avLst/>
@@ -3150,42 +3198,20 @@
           <a:noFill/>
         </p:spPr>
         <p:txBody>
-          <a:bodyPr wrap="square">
+          <a:bodyPr wrap="none">
             <a:spAutoFit/>
           </a:bodyPr>
           <a:lstStyle/>
           <a:p>
-            <a:pPr>
-              <a:defRPr sz="2000"/>
-            </a:pPr>
-          </a:p>
-          <a:p>
-            <a:pPr>
-              <a:defRPr sz="2000"/>
-            </a:pPr>
-            <a:r>
-              <a:t>UDP-based Reliable Data Transfer</a:t>
-            </a:r>
-          </a:p>
-          <a:p>
-            <a:pPr>
-              <a:defRPr sz="2000"/>
-            </a:pPr>
-            <a:r>
-              <a:t>with TCP Reno Congestion Control</a:t>
-            </a:r>
-          </a:p>
-          <a:p>
-            <a:pPr>
-              <a:defRPr sz="2000"/>
-            </a:pPr>
-          </a:p>
-          <a:p>
-            <a:pPr>
-              <a:defRPr sz="2000"/>
-            </a:pPr>
-            <a:r>
-              <a:t>Group XX</a:t>
+            <a:pPr algn="ctr">
+              <a:defRPr sz="2400">
+                <a:solidFill>
+                  <a:srgbClr val="DCDCDC"/>
+                </a:solidFill>
+              </a:defRPr>
+            </a:pPr>
+            <a:r>
+              <a:t>UDP-based RDT with TCP Reno Congestion Control</a:t>
             </a:r>
           </a:p>
         </p:txBody>
@@ -3210,14 +3236,57 @@
       <p:grpSpPr/>
       <p:sp>
         <p:nvSpPr>
-          <p:cNvPr id="2" name="TextBox 1"/>
+          <p:cNvPr id="2" name="Rectangle 1"/>
+          <p:cNvSpPr/>
+          <p:nvPr/>
+        </p:nvSpPr>
+        <p:spPr>
+          <a:xfrm>
+            <a:off x="0" y="0"/>
+            <a:ext cx="12191695" cy="914400"/>
+          </a:xfrm>
+          <a:prstGeom prst="rect">
+            <a:avLst/>
+          </a:prstGeom>
+          <a:solidFill>
+            <a:srgbClr val="003366"/>
+          </a:solidFill>
+          <a:ln>
+            <a:noFill/>
+          </a:ln>
+        </p:spPr>
+        <p:style>
+          <a:lnRef idx="1">
+            <a:schemeClr val="accent1"/>
+          </a:lnRef>
+          <a:fillRef idx="3">
+            <a:schemeClr val="accent1"/>
+          </a:fillRef>
+          <a:effectRef idx="2">
+            <a:schemeClr val="accent1"/>
+          </a:effectRef>
+          <a:fontRef idx="minor">
+            <a:schemeClr val="lt1"/>
+          </a:fontRef>
+        </p:style>
+        <p:txBody>
+          <a:bodyPr rtlCol="0" anchor="ctr"/>
+          <a:lstStyle/>
+          <a:p>
+            <a:pPr algn="ctr"/>
+          </a:p>
+        </p:txBody>
+      </p:sp>
+      <p:sp>
+        <p:nvSpPr>
+          <p:cNvPr id="3" name="TextBox 2"/>
           <p:cNvSpPr txBox="1"/>
           <p:nvPr/>
         </p:nvSpPr>
         <p:spPr>
           <a:xfrm>
-            <a:off x="457200" y="274320"/>
-            <a:ext cx="11277295" cy="731520"/>
+            <a:off x="457200" y="182880"/>
+            <a:ext cx="11277295" cy="548640"/>
           </a:xfrm>
           <a:prstGeom prst="rect">
             <a:avLst/>
@@ -3231,7 +3300,11 @@
           <a:lstStyle/>
           <a:p>
             <a:pPr>
-              <a:defRPr sz="3200" b="1"/>
+              <a:defRPr sz="2800" b="1">
+                <a:solidFill>
+                  <a:srgbClr val="FFFFFF"/>
+                </a:solidFill>
+              </a:defRPr>
             </a:pPr>
             <a:r>
               <a:t>Out-of-Order Handling</a:t>
@@ -3241,14 +3314,57 @@
       </p:sp>
       <p:sp>
         <p:nvSpPr>
-          <p:cNvPr id="3" name="TextBox 2"/>
+          <p:cNvPr id="4" name="Rectangle 3"/>
+          <p:cNvSpPr/>
+          <p:nvPr/>
+        </p:nvSpPr>
+        <p:spPr>
+          <a:xfrm>
+            <a:off x="274320" y="1097280"/>
+            <a:ext cx="11643055" cy="5486400"/>
+          </a:xfrm>
+          <a:prstGeom prst="rect">
+            <a:avLst/>
+          </a:prstGeom>
+          <a:solidFill>
+            <a:srgbClr val="282C34"/>
+          </a:solidFill>
+          <a:ln>
+            <a:noFill/>
+          </a:ln>
+        </p:spPr>
+        <p:style>
+          <a:lnRef idx="1">
+            <a:schemeClr val="accent1"/>
+          </a:lnRef>
+          <a:fillRef idx="3">
+            <a:schemeClr val="accent1"/>
+          </a:fillRef>
+          <a:effectRef idx="2">
+            <a:schemeClr val="accent1"/>
+          </a:effectRef>
+          <a:fontRef idx="minor">
+            <a:schemeClr val="lt1"/>
+          </a:fontRef>
+        </p:style>
+        <p:txBody>
+          <a:bodyPr rtlCol="0" anchor="ctr"/>
+          <a:lstStyle/>
+          <a:p>
+            <a:pPr algn="ctr"/>
+          </a:p>
+        </p:txBody>
+      </p:sp>
+      <p:sp>
+        <p:nvSpPr>
+          <p:cNvPr id="5" name="TextBox 4"/>
           <p:cNvSpPr txBox="1"/>
           <p:nvPr/>
         </p:nvSpPr>
         <p:spPr>
           <a:xfrm>
-            <a:off x="457200" y="1188720"/>
-            <a:ext cx="11277295" cy="5212080"/>
+            <a:off x="457200" y="1280160"/>
+            <a:ext cx="11277295" cy="5120640"/>
           </a:xfrm>
           <a:prstGeom prst="rect">
             <a:avLst/>
@@ -3262,74 +3378,142 @@
           <a:lstStyle/>
           <a:p>
             <a:pPr>
-              <a:defRPr sz="2000"/>
-            </a:pPr>
-            <a:r>
-              <a:t>if seq == next_seq:  # In-order</a:t>
-            </a:r>
-          </a:p>
-          <a:p>
-            <a:pPr>
-              <a:defRPr sz="2000"/>
-            </a:pPr>
-            <a:r>
-              <a:t>    received_packets[seq] = data</a:t>
-            </a:r>
-          </a:p>
-          <a:p>
-            <a:pPr>
-              <a:defRPr sz="2000"/>
-            </a:pPr>
-            <a:r>
-              <a:t>    next_seq += 1</a:t>
-            </a:r>
-          </a:p>
-          <a:p>
-            <a:pPr>
-              <a:defRPr sz="2000"/>
-            </a:pPr>
-            <a:r>
-              <a:t>    # Flush buffered packets</a:t>
-            </a:r>
-          </a:p>
-          <a:p>
-            <a:pPr>
-              <a:defRPr sz="2000"/>
-            </a:pPr>
-            <a:r>
-              <a:t>    while next_seq in out_of_order_buffer:</a:t>
-            </a:r>
-          </a:p>
-          <a:p>
-            <a:pPr>
-              <a:defRPr sz="2000"/>
-            </a:pPr>
-            <a:r>
-              <a:t>        received_packets[next_seq] = buffer.pop(next_seq)</a:t>
-            </a:r>
-          </a:p>
-          <a:p>
-            <a:pPr>
-              <a:defRPr sz="2000"/>
-            </a:pPr>
-            <a:r>
-              <a:t>        next_seq += 1</a:t>
-            </a:r>
-          </a:p>
-          <a:p>
-            <a:pPr>
-              <a:defRPr sz="2000"/>
-            </a:pPr>
-            <a:r>
-              <a:t>else:  # Out-of-order</a:t>
-            </a:r>
-          </a:p>
-          <a:p>
-            <a:pPr>
-              <a:defRPr sz="2000"/>
-            </a:pPr>
-            <a:r>
-              <a:t>    out_of_order_buffer[seq] = data</a:t>
+              <a:defRPr sz="1400">
+                <a:solidFill>
+                  <a:srgbClr val="ABB2BF"/>
+                </a:solidFill>
+                <a:latin typeface="Consolas"/>
+              </a:defRPr>
+            </a:pPr>
+            <a:r>
+              <a:t>def on_data_received(self, seq, data, is_last):</a:t>
+            </a:r>
+          </a:p>
+          <a:p>
+            <a:pPr>
+              <a:defRPr sz="1400">
+                <a:solidFill>
+                  <a:srgbClr val="ABB2BF"/>
+                </a:solidFill>
+                <a:latin typeface="Consolas"/>
+              </a:defRPr>
+            </a:pPr>
+            <a:r>
+              <a:t>    if seq == self.next_seq:  # In-order</a:t>
+            </a:r>
+          </a:p>
+          <a:p>
+            <a:pPr>
+              <a:defRPr sz="1400">
+                <a:solidFill>
+                  <a:srgbClr val="ABB2BF"/>
+                </a:solidFill>
+                <a:latin typeface="Consolas"/>
+              </a:defRPr>
+            </a:pPr>
+            <a:r>
+              <a:t>        self.received_packets[seq] = data</a:t>
+            </a:r>
+          </a:p>
+          <a:p>
+            <a:pPr>
+              <a:defRPr sz="1400">
+                <a:solidFill>
+                  <a:srgbClr val="ABB2BF"/>
+                </a:solidFill>
+                <a:latin typeface="Consolas"/>
+              </a:defRPr>
+            </a:pPr>
+            <a:r>
+              <a:t>        self.next_seq += 1</a:t>
+            </a:r>
+          </a:p>
+          <a:p>
+            <a:pPr>
+              <a:defRPr sz="1400">
+                <a:solidFill>
+                  <a:srgbClr val="ABB2BF"/>
+                </a:solidFill>
+                <a:latin typeface="Consolas"/>
+              </a:defRPr>
+            </a:pPr>
+          </a:p>
+          <a:p>
+            <a:pPr>
+              <a:defRPr sz="1400">
+                <a:solidFill>
+                  <a:srgbClr val="ABB2BF"/>
+                </a:solidFill>
+                <a:latin typeface="Consolas"/>
+              </a:defRPr>
+            </a:pPr>
+            <a:r>
+              <a:t>        while self.next_seq in self.out_of_order_buffer:</a:t>
+            </a:r>
+          </a:p>
+          <a:p>
+            <a:pPr>
+              <a:defRPr sz="1400">
+                <a:solidFill>
+                  <a:srgbClr val="ABB2BF"/>
+                </a:solidFill>
+                <a:latin typeface="Consolas"/>
+              </a:defRPr>
+            </a:pPr>
+            <a:r>
+              <a:t>            self.received_packets[self.next_seq] = \</a:t>
+            </a:r>
+          </a:p>
+          <a:p>
+            <a:pPr>
+              <a:defRPr sz="1400">
+                <a:solidFill>
+                  <a:srgbClr val="ABB2BF"/>
+                </a:solidFill>
+                <a:latin typeface="Consolas"/>
+              </a:defRPr>
+            </a:pPr>
+            <a:r>
+              <a:t>                self.out_of_order_buffer.pop(self.next_seq)</a:t>
+            </a:r>
+          </a:p>
+          <a:p>
+            <a:pPr>
+              <a:defRPr sz="1400">
+                <a:solidFill>
+                  <a:srgbClr val="ABB2BF"/>
+                </a:solidFill>
+                <a:latin typeface="Consolas"/>
+              </a:defRPr>
+            </a:pPr>
+            <a:r>
+              <a:t>            self.next_seq += 1</a:t>
+            </a:r>
+          </a:p>
+          <a:p>
+            <a:pPr>
+              <a:defRPr sz="1400">
+                <a:solidFill>
+                  <a:srgbClr val="ABB2BF"/>
+                </a:solidFill>
+                <a:latin typeface="Consolas"/>
+              </a:defRPr>
+            </a:pPr>
+            <a:r>
+              <a:t>    else:  # Out-of-order</a:t>
+            </a:r>
+          </a:p>
+          <a:p>
+            <a:pPr>
+              <a:defRPr sz="1400">
+                <a:solidFill>
+                  <a:srgbClr val="ABB2BF"/>
+                </a:solidFill>
+                <a:latin typeface="Consolas"/>
+              </a:defRPr>
+            </a:pPr>
+            <a:r>
+              <a:t>        self.out_of_order_buffer[seq] = data</a:t>
             </a:r>
           </a:p>
         </p:txBody>
@@ -3354,14 +3538,57 @@
       <p:grpSpPr/>
       <p:sp>
         <p:nvSpPr>
-          <p:cNvPr id="2" name="TextBox 1"/>
+          <p:cNvPr id="2" name="Rectangle 1"/>
+          <p:cNvSpPr/>
+          <p:nvPr/>
+        </p:nvSpPr>
+        <p:spPr>
+          <a:xfrm>
+            <a:off x="0" y="0"/>
+            <a:ext cx="12191695" cy="914400"/>
+          </a:xfrm>
+          <a:prstGeom prst="rect">
+            <a:avLst/>
+          </a:prstGeom>
+          <a:solidFill>
+            <a:srgbClr val="003366"/>
+          </a:solidFill>
+          <a:ln>
+            <a:noFill/>
+          </a:ln>
+        </p:spPr>
+        <p:style>
+          <a:lnRef idx="1">
+            <a:schemeClr val="accent1"/>
+          </a:lnRef>
+          <a:fillRef idx="3">
+            <a:schemeClr val="accent1"/>
+          </a:fillRef>
+          <a:effectRef idx="2">
+            <a:schemeClr val="accent1"/>
+          </a:effectRef>
+          <a:fontRef idx="minor">
+            <a:schemeClr val="lt1"/>
+          </a:fontRef>
+        </p:style>
+        <p:txBody>
+          <a:bodyPr rtlCol="0" anchor="ctr"/>
+          <a:lstStyle/>
+          <a:p>
+            <a:pPr algn="ctr"/>
+          </a:p>
+        </p:txBody>
+      </p:sp>
+      <p:sp>
+        <p:nvSpPr>
+          <p:cNvPr id="3" name="TextBox 2"/>
           <p:cNvSpPr txBox="1"/>
           <p:nvPr/>
         </p:nvSpPr>
         <p:spPr>
           <a:xfrm>
-            <a:off x="457200" y="274320"/>
-            <a:ext cx="11277295" cy="731520"/>
+            <a:off x="457200" y="182880"/>
+            <a:ext cx="11277295" cy="548640"/>
           </a:xfrm>
           <a:prstGeom prst="rect">
             <a:avLst/>
@@ -3375,7 +3602,11 @@
           <a:lstStyle/>
           <a:p>
             <a:pPr>
-              <a:defRPr sz="3200" b="1"/>
+              <a:defRPr sz="2800" b="1">
+                <a:solidFill>
+                  <a:srgbClr val="FFFFFF"/>
+                </a:solidFill>
+              </a:defRPr>
             </a:pPr>
             <a:r>
               <a:t>Crash Recovery</a:t>
@@ -3385,7 +3616,7 @@
       </p:sp>
       <p:sp>
         <p:nvSpPr>
-          <p:cNvPr id="3" name="TextBox 2"/>
+          <p:cNvPr id="4" name="TextBox 3"/>
           <p:cNvSpPr txBox="1"/>
           <p:nvPr/>
         </p:nvSpPr>
@@ -3406,76 +3637,140 @@
           <a:lstStyle/>
           <a:p>
             <a:pPr>
-              <a:defRPr sz="2000"/>
-            </a:pPr>
-            <a:r>
-              <a:t>Detection:</a:t>
-            </a:r>
-          </a:p>
-          <a:p>
-            <a:pPr>
-              <a:defRPr sz="2000"/>
-            </a:pPr>
-            <a:r>
-              <a:t>  • Monitor last_activity time</a:t>
-            </a:r>
-          </a:p>
-          <a:p>
-            <a:pPr>
-              <a:defRPr sz="2000"/>
-            </a:pPr>
-            <a:r>
-              <a:t>  • 8s warning, 12s crash detection</a:t>
-            </a:r>
-          </a:p>
-          <a:p>
-            <a:pPr>
-              <a:defRPr sz="2000"/>
-            </a:pPr>
-          </a:p>
-          <a:p>
-            <a:pPr>
-              <a:defRPr sz="2000"/>
-            </a:pPr>
-            <a:r>
-              <a:t>Recovery:</a:t>
-            </a:r>
-          </a:p>
-          <a:p>
-            <a:pPr>
-              <a:defRPr sz="2000"/>
-            </a:pPr>
-            <a:r>
-              <a:t>  • Mark peer as suspected</a:t>
-            </a:r>
-          </a:p>
-          <a:p>
-            <a:pPr>
-              <a:defRPr sz="2000"/>
-            </a:pPr>
-            <a:r>
-              <a:t>  • Find alternative peer from chunk_sources</a:t>
-            </a:r>
-          </a:p>
-          <a:p>
-            <a:pPr>
-              <a:defRPr sz="2000"/>
-            </a:pPr>
-            <a:r>
-              <a:t>  • Restart download from new peer</a:t>
-            </a:r>
-          </a:p>
-          <a:p>
-            <a:pPr>
-              <a:defRPr sz="2000"/>
-            </a:pPr>
-          </a:p>
-          <a:p>
-            <a:pPr>
-              <a:defRPr sz="2000"/>
-            </a:pPr>
-            <a:r>
-              <a:t>max_attempts = 5 per chunk</a:t>
+              <a:defRPr sz="1800">
+                <a:solidFill>
+                  <a:srgbClr val="323232"/>
+                </a:solidFill>
+              </a:defRPr>
+            </a:pPr>
+            <a:r>
+              <a:t>🔍 Detection:</a:t>
+            </a:r>
+          </a:p>
+          <a:p>
+            <a:pPr>
+              <a:defRPr sz="1800">
+                <a:solidFill>
+                  <a:srgbClr val="323232"/>
+                </a:solidFill>
+              </a:defRPr>
+            </a:pPr>
+            <a:r>
+              <a:t>    • Monitor last_activity time</a:t>
+            </a:r>
+          </a:p>
+          <a:p>
+            <a:pPr>
+              <a:defRPr sz="1800">
+                <a:solidFill>
+                  <a:srgbClr val="323232"/>
+                </a:solidFill>
+              </a:defRPr>
+            </a:pPr>
+            <a:r>
+              <a:t>    • 8s warning → 12s crash detection</a:t>
+            </a:r>
+          </a:p>
+          <a:p>
+            <a:pPr>
+              <a:defRPr sz="1800">
+                <a:solidFill>
+                  <a:srgbClr val="323232"/>
+                </a:solidFill>
+              </a:defRPr>
+            </a:pPr>
+          </a:p>
+          <a:p>
+            <a:pPr>
+              <a:defRPr sz="1800">
+                <a:solidFill>
+                  <a:srgbClr val="323232"/>
+                </a:solidFill>
+              </a:defRPr>
+            </a:pPr>
+            <a:r>
+              <a:t>🔄 Recovery:</a:t>
+            </a:r>
+          </a:p>
+          <a:p>
+            <a:pPr>
+              <a:defRPr sz="1800">
+                <a:solidFill>
+                  <a:srgbClr val="323232"/>
+                </a:solidFill>
+              </a:defRPr>
+            </a:pPr>
+            <a:r>
+              <a:t>    • Mark peer as suspected</a:t>
+            </a:r>
+          </a:p>
+          <a:p>
+            <a:pPr>
+              <a:defRPr sz="1800">
+                <a:solidFill>
+                  <a:srgbClr val="323232"/>
+                </a:solidFill>
+              </a:defRPr>
+            </a:pPr>
+            <a:r>
+              <a:t>    • Find alternative peer</a:t>
+            </a:r>
+          </a:p>
+          <a:p>
+            <a:pPr>
+              <a:defRPr sz="1800">
+                <a:solidFill>
+                  <a:srgbClr val="323232"/>
+                </a:solidFill>
+              </a:defRPr>
+            </a:pPr>
+            <a:r>
+              <a:t>    • Restart download</a:t>
+            </a:r>
+          </a:p>
+          <a:p>
+            <a:pPr>
+              <a:defRPr sz="1800">
+                <a:solidFill>
+                  <a:srgbClr val="323232"/>
+                </a:solidFill>
+              </a:defRPr>
+            </a:pPr>
+          </a:p>
+          <a:p>
+            <a:pPr>
+              <a:defRPr sz="1800">
+                <a:solidFill>
+                  <a:srgbClr val="323232"/>
+                </a:solidFill>
+              </a:defRPr>
+            </a:pPr>
+            <a:r>
+              <a:t>⚙️ Parameters:</a:t>
+            </a:r>
+          </a:p>
+          <a:p>
+            <a:pPr>
+              <a:defRPr sz="1800">
+                <a:solidFill>
+                  <a:srgbClr val="323232"/>
+                </a:solidFill>
+              </a:defRPr>
+            </a:pPr>
+            <a:r>
+              <a:t>    • peer_retry_delay: 5s</a:t>
+            </a:r>
+          </a:p>
+          <a:p>
+            <a:pPr>
+              <a:defRPr sz="1800">
+                <a:solidFill>
+                  <a:srgbClr val="323232"/>
+                </a:solidFill>
+              </a:defRPr>
+            </a:pPr>
+            <a:r>
+              <a:t>    • max_attempts: 5 per chunk</a:t>
             </a:r>
           </a:p>
         </p:txBody>
@@ -3500,14 +3795,57 @@
       <p:grpSpPr/>
       <p:sp>
         <p:nvSpPr>
-          <p:cNvPr id="2" name="TextBox 1"/>
+          <p:cNvPr id="2" name="Rectangle 1"/>
+          <p:cNvSpPr/>
+          <p:nvPr/>
+        </p:nvSpPr>
+        <p:spPr>
+          <a:xfrm>
+            <a:off x="0" y="0"/>
+            <a:ext cx="12191695" cy="914400"/>
+          </a:xfrm>
+          <a:prstGeom prst="rect">
+            <a:avLst/>
+          </a:prstGeom>
+          <a:solidFill>
+            <a:srgbClr val="003366"/>
+          </a:solidFill>
+          <a:ln>
+            <a:noFill/>
+          </a:ln>
+        </p:spPr>
+        <p:style>
+          <a:lnRef idx="1">
+            <a:schemeClr val="accent1"/>
+          </a:lnRef>
+          <a:fillRef idx="3">
+            <a:schemeClr val="accent1"/>
+          </a:fillRef>
+          <a:effectRef idx="2">
+            <a:schemeClr val="accent1"/>
+          </a:effectRef>
+          <a:fontRef idx="minor">
+            <a:schemeClr val="lt1"/>
+          </a:fontRef>
+        </p:style>
+        <p:txBody>
+          <a:bodyPr rtlCol="0" anchor="ctr"/>
+          <a:lstStyle/>
+          <a:p>
+            <a:pPr algn="ctr"/>
+          </a:p>
+        </p:txBody>
+      </p:sp>
+      <p:sp>
+        <p:nvSpPr>
+          <p:cNvPr id="3" name="TextBox 2"/>
           <p:cNvSpPr txBox="1"/>
           <p:nvPr/>
         </p:nvSpPr>
         <p:spPr>
           <a:xfrm>
-            <a:off x="457200" y="274320"/>
-            <a:ext cx="11277295" cy="731520"/>
+            <a:off x="457200" y="182880"/>
+            <a:ext cx="11277295" cy="548640"/>
           </a:xfrm>
           <a:prstGeom prst="rect">
             <a:avLst/>
@@ -3521,24 +3859,73 @@
           <a:lstStyle/>
           <a:p>
             <a:pPr>
-              <a:defRPr sz="3200" b="1"/>
-            </a:pPr>
-            <a:r>
-              <a:t>Concurrency Support</a:t>
-            </a:r>
-          </a:p>
-        </p:txBody>
-      </p:sp>
-      <p:sp>
-        <p:nvSpPr>
-          <p:cNvPr id="3" name="TextBox 2"/>
+              <a:defRPr sz="2800" b="1">
+                <a:solidFill>
+                  <a:srgbClr val="FFFFFF"/>
+                </a:solidFill>
+              </a:defRPr>
+            </a:pPr>
+            <a:r>
+              <a:t>Concurrency Visualization</a:t>
+            </a:r>
+          </a:p>
+        </p:txBody>
+      </p:sp>
+      <p:sp>
+        <p:nvSpPr>
+          <p:cNvPr id="4" name="Rectangle 3"/>
+          <p:cNvSpPr/>
+          <p:nvPr/>
+        </p:nvSpPr>
+        <p:spPr>
+          <a:xfrm>
+            <a:off x="457200" y="1188720"/>
+            <a:ext cx="11277295" cy="3657600"/>
+          </a:xfrm>
+          <a:prstGeom prst="rect">
+            <a:avLst/>
+          </a:prstGeom>
+          <a:solidFill>
+            <a:srgbClr val="FFFACD"/>
+          </a:solidFill>
+          <a:ln w="38100">
+            <a:solidFill>
+              <a:srgbClr val="FFC800"/>
+            </a:solidFill>
+          </a:ln>
+        </p:spPr>
+        <p:style>
+          <a:lnRef idx="1">
+            <a:schemeClr val="accent1"/>
+          </a:lnRef>
+          <a:fillRef idx="3">
+            <a:schemeClr val="accent1"/>
+          </a:fillRef>
+          <a:effectRef idx="2">
+            <a:schemeClr val="accent1"/>
+          </a:effectRef>
+          <a:fontRef idx="minor">
+            <a:schemeClr val="lt1"/>
+          </a:fontRef>
+        </p:style>
+        <p:txBody>
+          <a:bodyPr rtlCol="0" anchor="ctr"/>
+          <a:lstStyle/>
+          <a:p>
+            <a:pPr algn="ctr"/>
+          </a:p>
+        </p:txBody>
+      </p:sp>
+      <p:sp>
+        <p:nvSpPr>
+          <p:cNvPr id="5" name="TextBox 4"/>
           <p:cNvSpPr txBox="1"/>
           <p:nvPr/>
         </p:nvSpPr>
         <p:spPr>
           <a:xfrm>
-            <a:off x="457200" y="1188720"/>
-            <a:ext cx="11277295" cy="5212080"/>
+            <a:off x="914400" y="2286000"/>
+            <a:ext cx="10362895" cy="1828800"/>
           </a:xfrm>
           <a:prstGeom prst="rect">
             <a:avLst/>
@@ -3546,74 +3933,67 @@
           <a:noFill/>
         </p:spPr>
         <p:txBody>
+          <a:bodyPr wrap="none">
+            <a:spAutoFit/>
+          </a:bodyPr>
+          <a:lstStyle/>
+          <a:p>
+            <a:pPr algn="ctr">
+              <a:defRPr sz="2800">
+                <a:solidFill>
+                  <a:srgbClr val="966400"/>
+                </a:solidFill>
+              </a:defRPr>
+            </a:pPr>
+            <a:r>
+              <a:t>📊 INSERT CONCURRENCY PLOT HERE</a:t>
+            </a:r>
+          </a:p>
+        </p:txBody>
+      </p:sp>
+      <p:sp>
+        <p:nvSpPr>
+          <p:cNvPr id="6" name="TextBox 5"/>
+          <p:cNvSpPr txBox="1"/>
+          <p:nvPr/>
+        </p:nvSpPr>
+        <p:spPr>
+          <a:xfrm>
+            <a:off x="457200" y="5029200"/>
+            <a:ext cx="11277295" cy="1371600"/>
+          </a:xfrm>
+          <a:prstGeom prst="rect">
+            <a:avLst/>
+          </a:prstGeom>
+          <a:noFill/>
+        </p:spPr>
+        <p:txBody>
           <a:bodyPr wrap="square">
             <a:spAutoFit/>
           </a:bodyPr>
           <a:lstStyle/>
           <a:p>
             <a:pPr>
-              <a:defRPr sz="2000"/>
-            </a:pPr>
-            <a:r>
-              <a:t>Multi-peer Downloads:</a:t>
-            </a:r>
-          </a:p>
-          <a:p>
-            <a:pPr>
-              <a:defRPr sz="2000"/>
-            </a:pPr>
-            <a:r>
-              <a:t>  • DownloadManager schedules chunks to peers</a:t>
-            </a:r>
-          </a:p>
-          <a:p>
-            <a:pPr>
-              <a:defRPr sz="2000"/>
-            </a:pPr>
-            <a:r>
-              <a:t>  • One active download per peer</a:t>
-            </a:r>
-          </a:p>
-          <a:p>
-            <a:pPr>
-              <a:defRPr sz="2000"/>
-            </a:pPr>
-          </a:p>
-          <a:p>
-            <a:pPr>
-              <a:defRPr sz="2000"/>
-            </a:pPr>
-            <a:r>
-              <a:t>Upload Limiting:</a:t>
-            </a:r>
-          </a:p>
-          <a:p>
-            <a:pPr>
-              <a:defRPr sz="2000"/>
-            </a:pPr>
-            <a:r>
-              <a:t>  • max_conn limits concurrent uploads</a:t>
-            </a:r>
-          </a:p>
-          <a:p>
-            <a:pPr>
-              <a:defRPr sz="2000"/>
-            </a:pPr>
-            <a:r>
-              <a:t>  • DENIED packet when limit reached</a:t>
-            </a:r>
-          </a:p>
-          <a:p>
-            <a:pPr>
-              <a:defRPr sz="2000"/>
-            </a:pPr>
-          </a:p>
-          <a:p>
-            <a:pPr>
-              <a:defRPr sz="2000"/>
-            </a:pPr>
-            <a:r>
-              <a:t>[Insert concurrency plot here]</a:t>
+              <a:defRPr sz="1400" i="1">
+                <a:solidFill>
+                  <a:srgbClr val="646464"/>
+                </a:solidFill>
+              </a:defRPr>
+            </a:pPr>
+            <a:r>
+              <a:t>💡 Run: python3 test/concurrency_visualizer.py logs/peer1.log</a:t>
+            </a:r>
+          </a:p>
+          <a:p>
+            <a:pPr>
+              <a:defRPr sz="1400" i="1">
+                <a:solidFill>
+                  <a:srgbClr val="646464"/>
+                </a:solidFill>
+              </a:defRPr>
+            </a:pPr>
+            <a:r>
+              <a:t>💡 Shows parallel downloads from multiple peers</a:t>
             </a:r>
           </a:p>
         </p:txBody>
@@ -3638,14 +4018,57 @@
       <p:grpSpPr/>
       <p:sp>
         <p:nvSpPr>
-          <p:cNvPr id="2" name="TextBox 1"/>
+          <p:cNvPr id="2" name="Rectangle 1"/>
+          <p:cNvSpPr/>
+          <p:nvPr/>
+        </p:nvSpPr>
+        <p:spPr>
+          <a:xfrm>
+            <a:off x="0" y="0"/>
+            <a:ext cx="12191695" cy="914400"/>
+          </a:xfrm>
+          <a:prstGeom prst="rect">
+            <a:avLst/>
+          </a:prstGeom>
+          <a:solidFill>
+            <a:srgbClr val="003366"/>
+          </a:solidFill>
+          <a:ln>
+            <a:noFill/>
+          </a:ln>
+        </p:spPr>
+        <p:style>
+          <a:lnRef idx="1">
+            <a:schemeClr val="accent1"/>
+          </a:lnRef>
+          <a:fillRef idx="3">
+            <a:schemeClr val="accent1"/>
+          </a:fillRef>
+          <a:effectRef idx="2">
+            <a:schemeClr val="accent1"/>
+          </a:effectRef>
+          <a:fontRef idx="minor">
+            <a:schemeClr val="lt1"/>
+          </a:fontRef>
+        </p:style>
+        <p:txBody>
+          <a:bodyPr rtlCol="0" anchor="ctr"/>
+          <a:lstStyle/>
+          <a:p>
+            <a:pPr algn="ctr"/>
+          </a:p>
+        </p:txBody>
+      </p:sp>
+      <p:sp>
+        <p:nvSpPr>
+          <p:cNvPr id="3" name="TextBox 2"/>
           <p:cNvSpPr txBox="1"/>
           <p:nvPr/>
         </p:nvSpPr>
         <p:spPr>
           <a:xfrm>
-            <a:off x="457200" y="274320"/>
-            <a:ext cx="11277295" cy="731520"/>
+            <a:off x="457200" y="182880"/>
+            <a:ext cx="11277295" cy="548640"/>
           </a:xfrm>
           <a:prstGeom prst="rect">
             <a:avLst/>
@@ -3659,24 +4082,73 @@
           <a:lstStyle/>
           <a:p>
             <a:pPr>
-              <a:defRPr sz="3200" b="1"/>
-            </a:pPr>
-            <a:r>
-              <a:t>Optimizations</a:t>
-            </a:r>
-          </a:p>
-        </p:txBody>
-      </p:sp>
-      <p:sp>
-        <p:nvSpPr>
-          <p:cNvPr id="3" name="TextBox 2"/>
+              <a:defRPr sz="2800" b="1">
+                <a:solidFill>
+                  <a:srgbClr val="FFFFFF"/>
+                </a:solidFill>
+              </a:defRPr>
+            </a:pPr>
+            <a:r>
+              <a:t>Crash Recovery Test</a:t>
+            </a:r>
+          </a:p>
+        </p:txBody>
+      </p:sp>
+      <p:sp>
+        <p:nvSpPr>
+          <p:cNvPr id="4" name="Rectangle 3"/>
+          <p:cNvSpPr/>
+          <p:nvPr/>
+        </p:nvSpPr>
+        <p:spPr>
+          <a:xfrm>
+            <a:off x="457200" y="1188720"/>
+            <a:ext cx="11277295" cy="3657600"/>
+          </a:xfrm>
+          <a:prstGeom prst="rect">
+            <a:avLst/>
+          </a:prstGeom>
+          <a:solidFill>
+            <a:srgbClr val="FFFACD"/>
+          </a:solidFill>
+          <a:ln w="38100">
+            <a:solidFill>
+              <a:srgbClr val="FFC800"/>
+            </a:solidFill>
+          </a:ln>
+        </p:spPr>
+        <p:style>
+          <a:lnRef idx="1">
+            <a:schemeClr val="accent1"/>
+          </a:lnRef>
+          <a:fillRef idx="3">
+            <a:schemeClr val="accent1"/>
+          </a:fillRef>
+          <a:effectRef idx="2">
+            <a:schemeClr val="accent1"/>
+          </a:effectRef>
+          <a:fontRef idx="minor">
+            <a:schemeClr val="lt1"/>
+          </a:fontRef>
+        </p:style>
+        <p:txBody>
+          <a:bodyPr rtlCol="0" anchor="ctr"/>
+          <a:lstStyle/>
+          <a:p>
+            <a:pPr algn="ctr"/>
+          </a:p>
+        </p:txBody>
+      </p:sp>
+      <p:sp>
+        <p:nvSpPr>
+          <p:cNvPr id="5" name="TextBox 4"/>
           <p:cNvSpPr txBox="1"/>
           <p:nvPr/>
         </p:nvSpPr>
         <p:spPr>
           <a:xfrm>
-            <a:off x="457200" y="1188720"/>
-            <a:ext cx="11277295" cy="5212080"/>
+            <a:off x="914400" y="2286000"/>
+            <a:ext cx="10362895" cy="1828800"/>
           </a:xfrm>
           <a:prstGeom prst="rect">
             <a:avLst/>
@@ -3684,87 +4156,67 @@
           <a:noFill/>
         </p:spPr>
         <p:txBody>
+          <a:bodyPr wrap="none">
+            <a:spAutoFit/>
+          </a:bodyPr>
+          <a:lstStyle/>
+          <a:p>
+            <a:pPr algn="ctr">
+              <a:defRPr sz="2800">
+                <a:solidFill>
+                  <a:srgbClr val="966400"/>
+                </a:solidFill>
+              </a:defRPr>
+            </a:pPr>
+            <a:r>
+              <a:t>📊 INSERT CRASH TEST PLOT HERE</a:t>
+            </a:r>
+          </a:p>
+        </p:txBody>
+      </p:sp>
+      <p:sp>
+        <p:nvSpPr>
+          <p:cNvPr id="6" name="TextBox 5"/>
+          <p:cNvSpPr txBox="1"/>
+          <p:nvPr/>
+        </p:nvSpPr>
+        <p:spPr>
+          <a:xfrm>
+            <a:off x="457200" y="5029200"/>
+            <a:ext cx="11277295" cy="1371600"/>
+          </a:xfrm>
+          <a:prstGeom prst="rect">
+            <a:avLst/>
+          </a:prstGeom>
+          <a:noFill/>
+        </p:spPr>
+        <p:txBody>
           <a:bodyPr wrap="square">
             <a:spAutoFit/>
           </a:bodyPr>
           <a:lstStyle/>
           <a:p>
             <a:pPr>
-              <a:defRPr sz="2000"/>
-            </a:pPr>
-            <a:r>
-              <a:t>TCP Reno (vs Tahoe):</a:t>
-            </a:r>
-          </a:p>
-          <a:p>
-            <a:pPr>
-              <a:defRPr sz="2000"/>
-            </a:pPr>
-            <a:r>
-              <a:t>  • Fast Recovery avoids slow start on 3 dup ACKs</a:t>
-            </a:r>
-          </a:p>
-          <a:p>
-            <a:pPr>
-              <a:defRPr sz="2000"/>
-            </a:pPr>
-          </a:p>
-          <a:p>
-            <a:pPr>
-              <a:defRPr sz="2000"/>
-            </a:pPr>
-            <a:r>
-              <a:t>Selective Repeat Elements:</a:t>
-            </a:r>
-          </a:p>
-          <a:p>
-            <a:pPr>
-              <a:defRPr sz="2000"/>
-            </a:pPr>
-            <a:r>
-              <a:t>  • Out-of-order packet buffering</a:t>
-            </a:r>
-          </a:p>
-          <a:p>
-            <a:pPr>
-              <a:defRPr sz="2000"/>
-            </a:pPr>
-          </a:p>
-          <a:p>
-            <a:pPr>
-              <a:defRPr sz="2000"/>
-            </a:pPr>
-            <a:r>
-              <a:t>Crash Recovery:</a:t>
-            </a:r>
-          </a:p>
-          <a:p>
-            <a:pPr>
-              <a:defRPr sz="2000"/>
-            </a:pPr>
-            <a:r>
-              <a:t>  • Automatic peer failover</a:t>
-            </a:r>
-          </a:p>
-          <a:p>
-            <a:pPr>
-              <a:defRPr sz="2000"/>
-            </a:pPr>
-          </a:p>
-          <a:p>
-            <a:pPr>
-              <a:defRPr sz="2000"/>
-            </a:pPr>
-            <a:r>
-              <a:t>Dynamic Timeout:</a:t>
-            </a:r>
-          </a:p>
-          <a:p>
-            <a:pPr>
-              <a:defRPr sz="2000"/>
-            </a:pPr>
-            <a:r>
-              <a:t>  • RTT-based timeout adjustment</a:t>
+              <a:defRPr sz="1400" i="1">
+                <a:solidFill>
+                  <a:srgbClr val="646464"/>
+                </a:solidFill>
+              </a:defRPr>
+            </a:pPr>
+            <a:r>
+              <a:t>💡 Run: python3 test/concurrency_visualizer.py logs/peer1.log</a:t>
+            </a:r>
+          </a:p>
+          <a:p>
+            <a:pPr>
+              <a:defRPr sz="1400" i="1">
+                <a:solidFill>
+                  <a:srgbClr val="646464"/>
+                </a:solidFill>
+              </a:defRPr>
+            </a:pPr>
+            <a:r>
+              <a:t>💡 Run after crash test to show peer failover</a:t>
             </a:r>
           </a:p>
         </p:txBody>
@@ -3789,14 +4241,57 @@
       <p:grpSpPr/>
       <p:sp>
         <p:nvSpPr>
-          <p:cNvPr id="2" name="TextBox 1"/>
+          <p:cNvPr id="2" name="Rectangle 1"/>
+          <p:cNvSpPr/>
+          <p:nvPr/>
+        </p:nvSpPr>
+        <p:spPr>
+          <a:xfrm>
+            <a:off x="0" y="0"/>
+            <a:ext cx="12191695" cy="914400"/>
+          </a:xfrm>
+          <a:prstGeom prst="rect">
+            <a:avLst/>
+          </a:prstGeom>
+          <a:solidFill>
+            <a:srgbClr val="003366"/>
+          </a:solidFill>
+          <a:ln>
+            <a:noFill/>
+          </a:ln>
+        </p:spPr>
+        <p:style>
+          <a:lnRef idx="1">
+            <a:schemeClr val="accent1"/>
+          </a:lnRef>
+          <a:fillRef idx="3">
+            <a:schemeClr val="accent1"/>
+          </a:fillRef>
+          <a:effectRef idx="2">
+            <a:schemeClr val="accent1"/>
+          </a:effectRef>
+          <a:fontRef idx="minor">
+            <a:schemeClr val="lt1"/>
+          </a:fontRef>
+        </p:style>
+        <p:txBody>
+          <a:bodyPr rtlCol="0" anchor="ctr"/>
+          <a:lstStyle/>
+          <a:p>
+            <a:pPr algn="ctr"/>
+          </a:p>
+        </p:txBody>
+      </p:sp>
+      <p:sp>
+        <p:nvSpPr>
+          <p:cNvPr id="3" name="TextBox 2"/>
           <p:cNvSpPr txBox="1"/>
           <p:nvPr/>
         </p:nvSpPr>
         <p:spPr>
           <a:xfrm>
-            <a:off x="457200" y="274320"/>
-            <a:ext cx="11277295" cy="731520"/>
+            <a:off x="457200" y="182880"/>
+            <a:ext cx="11277295" cy="548640"/>
           </a:xfrm>
           <a:prstGeom prst="rect">
             <a:avLst/>
@@ -3810,17 +4305,21 @@
           <a:lstStyle/>
           <a:p>
             <a:pPr>
-              <a:defRPr sz="3200" b="1"/>
-            </a:pPr>
-            <a:r>
-              <a:t>Summary</a:t>
-            </a:r>
-          </a:p>
-        </p:txBody>
-      </p:sp>
-      <p:sp>
-        <p:nvSpPr>
-          <p:cNvPr id="3" name="TextBox 2"/>
+              <a:defRPr sz="2800" b="1">
+                <a:solidFill>
+                  <a:srgbClr val="FFFFFF"/>
+                </a:solidFill>
+              </a:defRPr>
+            </a:pPr>
+            <a:r>
+              <a:t>Optimizations</a:t>
+            </a:r>
+          </a:p>
+        </p:txBody>
+      </p:sp>
+      <p:sp>
+        <p:nvSpPr>
+          <p:cNvPr id="4" name="TextBox 3"/>
           <p:cNvSpPr txBox="1"/>
           <p:nvPr/>
         </p:nvSpPr>
@@ -3841,60 +4340,125 @@
           <a:lstStyle/>
           <a:p>
             <a:pPr>
-              <a:defRPr sz="2000"/>
-            </a:pPr>
-            <a:r>
-              <a:t>Implemented P2P file transfer with:</a:t>
-            </a:r>
-          </a:p>
-          <a:p>
-            <a:pPr>
-              <a:defRPr sz="2000"/>
-            </a:pPr>
-          </a:p>
-          <a:p>
-            <a:pPr>
-              <a:defRPr sz="2000"/>
-            </a:pPr>
-            <a:r>
-              <a:t>• Reliable Data Transfer over UDP</a:t>
-            </a:r>
-          </a:p>
-          <a:p>
-            <a:pPr>
-              <a:defRPr sz="2000"/>
-            </a:pPr>
-            <a:r>
-              <a:t>• TCP Reno Congestion Control</a:t>
-            </a:r>
-          </a:p>
-          <a:p>
-            <a:pPr>
-              <a:defRPr sz="2000"/>
-            </a:pPr>
-            <a:r>
-              <a:t>• Out-of-order Packet Handling</a:t>
-            </a:r>
-          </a:p>
-          <a:p>
-            <a:pPr>
-              <a:defRPr sz="2000"/>
-            </a:pPr>
-            <a:r>
-              <a:t>• Multi-peer Download with Crash Recovery</a:t>
-            </a:r>
-          </a:p>
-          <a:p>
-            <a:pPr>
-              <a:defRPr sz="2000"/>
-            </a:pPr>
-          </a:p>
-          <a:p>
-            <a:pPr>
-              <a:defRPr sz="2000"/>
-            </a:pPr>
-            <a:r>
-              <a:t>Key Classes: TransferSession, PeerState, DownloadManager</a:t>
+              <a:defRPr sz="1800">
+                <a:solidFill>
+                  <a:srgbClr val="323232"/>
+                </a:solidFill>
+              </a:defRPr>
+            </a:pPr>
+            <a:r>
+              <a:t>🚀 TCP Reno (vs Tahoe):</a:t>
+            </a:r>
+          </a:p>
+          <a:p>
+            <a:pPr>
+              <a:defRPr sz="1800">
+                <a:solidFill>
+                  <a:srgbClr val="323232"/>
+                </a:solidFill>
+              </a:defRPr>
+            </a:pPr>
+            <a:r>
+              <a:t>    • Fast Recovery on 3 dup ACKs</a:t>
+            </a:r>
+          </a:p>
+          <a:p>
+            <a:pPr>
+              <a:defRPr sz="1800">
+                <a:solidFill>
+                  <a:srgbClr val="323232"/>
+                </a:solidFill>
+              </a:defRPr>
+            </a:pPr>
+          </a:p>
+          <a:p>
+            <a:pPr>
+              <a:defRPr sz="1800">
+                <a:solidFill>
+                  <a:srgbClr val="323232"/>
+                </a:solidFill>
+              </a:defRPr>
+            </a:pPr>
+            <a:r>
+              <a:t>📦 Selective Repeat:</a:t>
+            </a:r>
+          </a:p>
+          <a:p>
+            <a:pPr>
+              <a:defRPr sz="1800">
+                <a:solidFill>
+                  <a:srgbClr val="323232"/>
+                </a:solidFill>
+              </a:defRPr>
+            </a:pPr>
+            <a:r>
+              <a:t>    • Out-of-order packet buffering</a:t>
+            </a:r>
+          </a:p>
+          <a:p>
+            <a:pPr>
+              <a:defRPr sz="1800">
+                <a:solidFill>
+                  <a:srgbClr val="323232"/>
+                </a:solidFill>
+              </a:defRPr>
+            </a:pPr>
+          </a:p>
+          <a:p>
+            <a:pPr>
+              <a:defRPr sz="1800">
+                <a:solidFill>
+                  <a:srgbClr val="323232"/>
+                </a:solidFill>
+              </a:defRPr>
+            </a:pPr>
+            <a:r>
+              <a:t>💪 Crash Recovery:</a:t>
+            </a:r>
+          </a:p>
+          <a:p>
+            <a:pPr>
+              <a:defRPr sz="1800">
+                <a:solidFill>
+                  <a:srgbClr val="323232"/>
+                </a:solidFill>
+              </a:defRPr>
+            </a:pPr>
+            <a:r>
+              <a:t>    • Automatic peer failover</a:t>
+            </a:r>
+          </a:p>
+          <a:p>
+            <a:pPr>
+              <a:defRPr sz="1800">
+                <a:solidFill>
+                  <a:srgbClr val="323232"/>
+                </a:solidFill>
+              </a:defRPr>
+            </a:pPr>
+          </a:p>
+          <a:p>
+            <a:pPr>
+              <a:defRPr sz="1800">
+                <a:solidFill>
+                  <a:srgbClr val="323232"/>
+                </a:solidFill>
+              </a:defRPr>
+            </a:pPr>
+            <a:r>
+              <a:t>⏱️ Dynamic Timeout:</a:t>
+            </a:r>
+          </a:p>
+          <a:p>
+            <a:pPr>
+              <a:defRPr sz="1800">
+                <a:solidFill>
+                  <a:srgbClr val="323232"/>
+                </a:solidFill>
+              </a:defRPr>
+            </a:pPr>
+            <a:r>
+              <a:t>    • RFC 6298 RTT estimation</a:t>
             </a:r>
           </a:p>
         </p:txBody>
@@ -3919,14 +4483,57 @@
       <p:grpSpPr/>
       <p:sp>
         <p:nvSpPr>
-          <p:cNvPr id="2" name="TextBox 1"/>
+          <p:cNvPr id="2" name="Rectangle 1"/>
+          <p:cNvSpPr/>
+          <p:nvPr/>
+        </p:nvSpPr>
+        <p:spPr>
+          <a:xfrm>
+            <a:off x="0" y="0"/>
+            <a:ext cx="12191695" cy="914400"/>
+          </a:xfrm>
+          <a:prstGeom prst="rect">
+            <a:avLst/>
+          </a:prstGeom>
+          <a:solidFill>
+            <a:srgbClr val="003366"/>
+          </a:solidFill>
+          <a:ln>
+            <a:noFill/>
+          </a:ln>
+        </p:spPr>
+        <p:style>
+          <a:lnRef idx="1">
+            <a:schemeClr val="accent1"/>
+          </a:lnRef>
+          <a:fillRef idx="3">
+            <a:schemeClr val="accent1"/>
+          </a:fillRef>
+          <a:effectRef idx="2">
+            <a:schemeClr val="accent1"/>
+          </a:effectRef>
+          <a:fontRef idx="minor">
+            <a:schemeClr val="lt1"/>
+          </a:fontRef>
+        </p:style>
+        <p:txBody>
+          <a:bodyPr rtlCol="0" anchor="ctr"/>
+          <a:lstStyle/>
+          <a:p>
+            <a:pPr algn="ctr"/>
+          </a:p>
+        </p:txBody>
+      </p:sp>
+      <p:sp>
+        <p:nvSpPr>
+          <p:cNvPr id="3" name="TextBox 2"/>
           <p:cNvSpPr txBox="1"/>
           <p:nvPr/>
         </p:nvSpPr>
         <p:spPr>
           <a:xfrm>
-            <a:off x="457200" y="274320"/>
-            <a:ext cx="11277295" cy="731520"/>
+            <a:off x="457200" y="182880"/>
+            <a:ext cx="11277295" cy="548640"/>
           </a:xfrm>
           <a:prstGeom prst="rect">
             <a:avLst/>
@@ -3940,17 +4547,21 @@
           <a:lstStyle/>
           <a:p>
             <a:pPr>
-              <a:defRPr sz="3200" b="1"/>
-            </a:pPr>
-            <a:r>
-              <a:t>Contribution Rate</a:t>
-            </a:r>
-          </a:p>
-        </p:txBody>
-      </p:sp>
-      <p:sp>
-        <p:nvSpPr>
-          <p:cNvPr id="3" name="TextBox 2"/>
+              <a:defRPr sz="2800" b="1">
+                <a:solidFill>
+                  <a:srgbClr val="FFFFFF"/>
+                </a:solidFill>
+              </a:defRPr>
+            </a:pPr>
+            <a:r>
+              <a:t>Summary</a:t>
+            </a:r>
+          </a:p>
+        </p:txBody>
+      </p:sp>
+      <p:sp>
+        <p:nvSpPr>
+          <p:cNvPr id="4" name="TextBox 3"/>
           <p:cNvSpPr txBox="1"/>
           <p:nvPr/>
         </p:nvSpPr>
@@ -3971,36 +4582,342 @@
           <a:lstStyle/>
           <a:p>
             <a:pPr>
-              <a:defRPr sz="2000"/>
-            </a:pPr>
-          </a:p>
-          <a:p>
-            <a:pPr>
-              <a:defRPr sz="2000"/>
-            </a:pPr>
-            <a:r>
-              <a:t>Member 1: XX%</a:t>
-            </a:r>
-          </a:p>
-          <a:p>
-            <a:pPr>
-              <a:defRPr sz="2000"/>
-            </a:pPr>
-            <a:r>
-              <a:t>Member 2: XX%</a:t>
-            </a:r>
-          </a:p>
-          <a:p>
-            <a:pPr>
-              <a:defRPr sz="2000"/>
-            </a:pPr>
-          </a:p>
-          <a:p>
-            <a:pPr>
-              <a:defRPr sz="2000"/>
-            </a:pPr>
-            <a:r>
-              <a:t>(Adjust based on actual contribution)</a:t>
+              <a:defRPr sz="1800">
+                <a:solidFill>
+                  <a:srgbClr val="323232"/>
+                </a:solidFill>
+              </a:defRPr>
+            </a:pPr>
+            <a:r>
+              <a:t>✅ Implemented:</a:t>
+            </a:r>
+          </a:p>
+          <a:p>
+            <a:pPr>
+              <a:defRPr sz="1800">
+                <a:solidFill>
+                  <a:srgbClr val="323232"/>
+                </a:solidFill>
+              </a:defRPr>
+            </a:pPr>
+            <a:r>
+              <a:t>    • Reliable Data Transfer over UDP</a:t>
+            </a:r>
+          </a:p>
+          <a:p>
+            <a:pPr>
+              <a:defRPr sz="1800">
+                <a:solidFill>
+                  <a:srgbClr val="323232"/>
+                </a:solidFill>
+              </a:defRPr>
+            </a:pPr>
+            <a:r>
+              <a:t>    • TCP Reno Congestion Control</a:t>
+            </a:r>
+          </a:p>
+          <a:p>
+            <a:pPr>
+              <a:defRPr sz="1800">
+                <a:solidFill>
+                  <a:srgbClr val="323232"/>
+                </a:solidFill>
+              </a:defRPr>
+            </a:pPr>
+            <a:r>
+              <a:t>    • Out-of-order Handling</a:t>
+            </a:r>
+          </a:p>
+          <a:p>
+            <a:pPr>
+              <a:defRPr sz="1800">
+                <a:solidFill>
+                  <a:srgbClr val="323232"/>
+                </a:solidFill>
+              </a:defRPr>
+            </a:pPr>
+            <a:r>
+              <a:t>    • Multi-peer Download</a:t>
+            </a:r>
+          </a:p>
+          <a:p>
+            <a:pPr>
+              <a:defRPr sz="1800">
+                <a:solidFill>
+                  <a:srgbClr val="323232"/>
+                </a:solidFill>
+              </a:defRPr>
+            </a:pPr>
+            <a:r>
+              <a:t>    • Crash Recovery</a:t>
+            </a:r>
+          </a:p>
+          <a:p>
+            <a:pPr>
+              <a:defRPr sz="1800">
+                <a:solidFill>
+                  <a:srgbClr val="323232"/>
+                </a:solidFill>
+              </a:defRPr>
+            </a:pPr>
+          </a:p>
+          <a:p>
+            <a:pPr>
+              <a:defRPr sz="1800">
+                <a:solidFill>
+                  <a:srgbClr val="323232"/>
+                </a:solidFill>
+              </a:defRPr>
+            </a:pPr>
+            <a:r>
+              <a:t>🏗️ Key Classes:</a:t>
+            </a:r>
+          </a:p>
+          <a:p>
+            <a:pPr>
+              <a:defRPr sz="1800">
+                <a:solidFill>
+                  <a:srgbClr val="323232"/>
+                </a:solidFill>
+              </a:defRPr>
+            </a:pPr>
+            <a:r>
+              <a:t>    • TransferSession, PeerState, DownloadManager</a:t>
+            </a:r>
+          </a:p>
+        </p:txBody>
+      </p:sp>
+    </p:spTree>
+  </p:cSld>
+  <p:clrMapOvr>
+    <a:masterClrMapping/>
+  </p:clrMapOvr>
+</p:sld>
+</file>
+
+<file path=ppt/slides/slide16.xml><?xml version="1.0" encoding="utf-8"?>
+<p:sld xmlns:a="http://schemas.openxmlformats.org/drawingml/2006/main" xmlns:p="http://schemas.openxmlformats.org/presentationml/2006/main" xmlns:r="http://schemas.openxmlformats.org/officeDocument/2006/relationships">
+  <p:cSld>
+    <p:spTree>
+      <p:nvGrpSpPr>
+        <p:cNvPr id="1" name=""/>
+        <p:cNvGrpSpPr/>
+        <p:nvPr/>
+      </p:nvGrpSpPr>
+      <p:grpSpPr/>
+      <p:sp>
+        <p:nvSpPr>
+          <p:cNvPr id="2" name="Rectangle 1"/>
+          <p:cNvSpPr/>
+          <p:nvPr/>
+        </p:nvSpPr>
+        <p:spPr>
+          <a:xfrm>
+            <a:off x="0" y="0"/>
+            <a:ext cx="12191695" cy="914400"/>
+          </a:xfrm>
+          <a:prstGeom prst="rect">
+            <a:avLst/>
+          </a:prstGeom>
+          <a:solidFill>
+            <a:srgbClr val="003366"/>
+          </a:solidFill>
+          <a:ln>
+            <a:noFill/>
+          </a:ln>
+        </p:spPr>
+        <p:style>
+          <a:lnRef idx="1">
+            <a:schemeClr val="accent1"/>
+          </a:lnRef>
+          <a:fillRef idx="3">
+            <a:schemeClr val="accent1"/>
+          </a:fillRef>
+          <a:effectRef idx="2">
+            <a:schemeClr val="accent1"/>
+          </a:effectRef>
+          <a:fontRef idx="minor">
+            <a:schemeClr val="lt1"/>
+          </a:fontRef>
+        </p:style>
+        <p:txBody>
+          <a:bodyPr rtlCol="0" anchor="ctr"/>
+          <a:lstStyle/>
+          <a:p>
+            <a:pPr algn="ctr"/>
+          </a:p>
+        </p:txBody>
+      </p:sp>
+      <p:sp>
+        <p:nvSpPr>
+          <p:cNvPr id="3" name="TextBox 2"/>
+          <p:cNvSpPr txBox="1"/>
+          <p:nvPr/>
+        </p:nvSpPr>
+        <p:spPr>
+          <a:xfrm>
+            <a:off x="457200" y="182880"/>
+            <a:ext cx="11277295" cy="548640"/>
+          </a:xfrm>
+          <a:prstGeom prst="rect">
+            <a:avLst/>
+          </a:prstGeom>
+          <a:noFill/>
+        </p:spPr>
+        <p:txBody>
+          <a:bodyPr wrap="none">
+            <a:spAutoFit/>
+          </a:bodyPr>
+          <a:lstStyle/>
+          <a:p>
+            <a:pPr>
+              <a:defRPr sz="2800" b="1">
+                <a:solidFill>
+                  <a:srgbClr val="FFFFFF"/>
+                </a:solidFill>
+              </a:defRPr>
+            </a:pPr>
+            <a:r>
+              <a:t>Contribution Rate</a:t>
+            </a:r>
+          </a:p>
+        </p:txBody>
+      </p:sp>
+      <p:sp>
+        <p:nvSpPr>
+          <p:cNvPr id="4" name="Rectangle 3"/>
+          <p:cNvSpPr/>
+          <p:nvPr/>
+        </p:nvSpPr>
+        <p:spPr>
+          <a:xfrm>
+            <a:off x="457200" y="1188720"/>
+            <a:ext cx="11277295" cy="3657600"/>
+          </a:xfrm>
+          <a:prstGeom prst="rect">
+            <a:avLst/>
+          </a:prstGeom>
+          <a:solidFill>
+            <a:srgbClr val="FFFACD"/>
+          </a:solidFill>
+          <a:ln w="38100">
+            <a:solidFill>
+              <a:srgbClr val="FFC800"/>
+            </a:solidFill>
+          </a:ln>
+        </p:spPr>
+        <p:style>
+          <a:lnRef idx="1">
+            <a:schemeClr val="accent1"/>
+          </a:lnRef>
+          <a:fillRef idx="3">
+            <a:schemeClr val="accent1"/>
+          </a:fillRef>
+          <a:effectRef idx="2">
+            <a:schemeClr val="accent1"/>
+          </a:effectRef>
+          <a:fontRef idx="minor">
+            <a:schemeClr val="lt1"/>
+          </a:fontRef>
+        </p:style>
+        <p:txBody>
+          <a:bodyPr rtlCol="0" anchor="ctr"/>
+          <a:lstStyle/>
+          <a:p>
+            <a:pPr algn="ctr"/>
+          </a:p>
+        </p:txBody>
+      </p:sp>
+      <p:sp>
+        <p:nvSpPr>
+          <p:cNvPr id="5" name="TextBox 4"/>
+          <p:cNvSpPr txBox="1"/>
+          <p:nvPr/>
+        </p:nvSpPr>
+        <p:spPr>
+          <a:xfrm>
+            <a:off x="914400" y="2286000"/>
+            <a:ext cx="10362895" cy="1828800"/>
+          </a:xfrm>
+          <a:prstGeom prst="rect">
+            <a:avLst/>
+          </a:prstGeom>
+          <a:noFill/>
+        </p:spPr>
+        <p:txBody>
+          <a:bodyPr wrap="none">
+            <a:spAutoFit/>
+          </a:bodyPr>
+          <a:lstStyle/>
+          <a:p>
+            <a:pPr algn="ctr">
+              <a:defRPr sz="2800">
+                <a:solidFill>
+                  <a:srgbClr val="966400"/>
+                </a:solidFill>
+              </a:defRPr>
+            </a:pPr>
+            <a:r>
+              <a:t>📝 FILL IN TEAM CONTRIBUTIONS</a:t>
+            </a:r>
+          </a:p>
+        </p:txBody>
+      </p:sp>
+      <p:sp>
+        <p:nvSpPr>
+          <p:cNvPr id="6" name="TextBox 5"/>
+          <p:cNvSpPr txBox="1"/>
+          <p:nvPr/>
+        </p:nvSpPr>
+        <p:spPr>
+          <a:xfrm>
+            <a:off x="457200" y="5029200"/>
+            <a:ext cx="11277295" cy="1371600"/>
+          </a:xfrm>
+          <a:prstGeom prst="rect">
+            <a:avLst/>
+          </a:prstGeom>
+          <a:noFill/>
+        </p:spPr>
+        <p:txBody>
+          <a:bodyPr wrap="square">
+            <a:spAutoFit/>
+          </a:bodyPr>
+          <a:lstStyle/>
+          <a:p>
+            <a:pPr>
+              <a:defRPr sz="1400" i="1">
+                <a:solidFill>
+                  <a:srgbClr val="646464"/>
+                </a:solidFill>
+              </a:defRPr>
+            </a:pPr>
+            <a:r>
+              <a:t>💡 List each member and percentage</a:t>
+            </a:r>
+          </a:p>
+          <a:p>
+            <a:pPr>
+              <a:defRPr sz="1400" i="1">
+                <a:solidFill>
+                  <a:srgbClr val="646464"/>
+                </a:solidFill>
+              </a:defRPr>
+            </a:pPr>
+            <a:r>
+              <a:t>💡 Example: Member A: 50%, Member B: 50%</a:t>
+            </a:r>
+          </a:p>
+          <a:p>
+            <a:pPr>
+              <a:defRPr sz="1400" i="1">
+                <a:solidFill>
+                  <a:srgbClr val="646464"/>
+                </a:solidFill>
+              </a:defRPr>
+            </a:pPr>
+            <a:r>
+              <a:t>💡 Must sum to 100%</a:t>
             </a:r>
           </a:p>
         </p:txBody>
@@ -4025,14 +4942,57 @@
       <p:grpSpPr/>
       <p:sp>
         <p:nvSpPr>
-          <p:cNvPr id="2" name="TextBox 1"/>
+          <p:cNvPr id="2" name="Rectangle 1"/>
+          <p:cNvSpPr/>
+          <p:nvPr/>
+        </p:nvSpPr>
+        <p:spPr>
+          <a:xfrm>
+            <a:off x="0" y="0"/>
+            <a:ext cx="12191695" cy="914400"/>
+          </a:xfrm>
+          <a:prstGeom prst="rect">
+            <a:avLst/>
+          </a:prstGeom>
+          <a:solidFill>
+            <a:srgbClr val="003366"/>
+          </a:solidFill>
+          <a:ln>
+            <a:noFill/>
+          </a:ln>
+        </p:spPr>
+        <p:style>
+          <a:lnRef idx="1">
+            <a:schemeClr val="accent1"/>
+          </a:lnRef>
+          <a:fillRef idx="3">
+            <a:schemeClr val="accent1"/>
+          </a:fillRef>
+          <a:effectRef idx="2">
+            <a:schemeClr val="accent1"/>
+          </a:effectRef>
+          <a:fontRef idx="minor">
+            <a:schemeClr val="lt1"/>
+          </a:fontRef>
+        </p:style>
+        <p:txBody>
+          <a:bodyPr rtlCol="0" anchor="ctr"/>
+          <a:lstStyle/>
+          <a:p>
+            <a:pPr algn="ctr"/>
+          </a:p>
+        </p:txBody>
+      </p:sp>
+      <p:sp>
+        <p:nvSpPr>
+          <p:cNvPr id="3" name="TextBox 2"/>
           <p:cNvSpPr txBox="1"/>
           <p:nvPr/>
         </p:nvSpPr>
         <p:spPr>
           <a:xfrm>
-            <a:off x="457200" y="274320"/>
-            <a:ext cx="11277295" cy="731520"/>
+            <a:off x="457200" y="182880"/>
+            <a:ext cx="11277295" cy="548640"/>
           </a:xfrm>
           <a:prstGeom prst="rect">
             <a:avLst/>
@@ -4046,7 +5006,11 @@
           <a:lstStyle/>
           <a:p>
             <a:pPr>
-              <a:defRPr sz="3200" b="1"/>
+              <a:defRPr sz="2800" b="1">
+                <a:solidFill>
+                  <a:srgbClr val="FFFFFF"/>
+                </a:solidFill>
+              </a:defRPr>
             </a:pPr>
             <a:r>
               <a:t>Project Overview</a:t>
@@ -4056,7 +5020,7 @@
       </p:sp>
       <p:sp>
         <p:nvSpPr>
-          <p:cNvPr id="3" name="TextBox 2"/>
+          <p:cNvPr id="4" name="TextBox 3"/>
           <p:cNvSpPr txBox="1"/>
           <p:nvPr/>
         </p:nvSpPr>
@@ -4077,50 +5041,95 @@
           <a:lstStyle/>
           <a:p>
             <a:pPr>
-              <a:defRPr sz="2000"/>
-            </a:pPr>
-            <a:r>
-              <a:t>• Reliable Data Transfer (RDT) over unreliable UDP</a:t>
-            </a:r>
-          </a:p>
-          <a:p>
-            <a:pPr>
-              <a:defRPr sz="2000"/>
-            </a:pPr>
-            <a:r>
-              <a:t>• TCP Reno Congestion Control</a:t>
-            </a:r>
-          </a:p>
-          <a:p>
-            <a:pPr>
-              <a:defRPr sz="2000"/>
-            </a:pPr>
-            <a:r>
-              <a:t>  - Slow Start, Congestion Avoidance, Fast Recovery</a:t>
-            </a:r>
-          </a:p>
-          <a:p>
-            <a:pPr>
-              <a:defRPr sz="2000"/>
-            </a:pPr>
-            <a:r>
-              <a:t>• Chunk-based File Transfer with SHA1 verification</a:t>
-            </a:r>
-          </a:p>
-          <a:p>
-            <a:pPr>
-              <a:defRPr sz="2000"/>
-            </a:pPr>
-            <a:r>
-              <a:t>• Multi-peer Download Support</a:t>
-            </a:r>
-          </a:p>
-          <a:p>
-            <a:pPr>
-              <a:defRPr sz="2000"/>
-            </a:pPr>
-            <a:r>
-              <a:t>• Automatic Crash Recovery</a:t>
+              <a:defRPr sz="1800">
+                <a:solidFill>
+                  <a:srgbClr val="323232"/>
+                </a:solidFill>
+              </a:defRPr>
+            </a:pPr>
+            <a:r>
+              <a:t>🎯 Goal: Reliable file transfer over unreliable UDP</a:t>
+            </a:r>
+          </a:p>
+          <a:p>
+            <a:pPr>
+              <a:defRPr sz="1800">
+                <a:solidFill>
+                  <a:srgbClr val="323232"/>
+                </a:solidFill>
+              </a:defRPr>
+            </a:pPr>
+          </a:p>
+          <a:p>
+            <a:pPr>
+              <a:defRPr sz="1800">
+                <a:solidFill>
+                  <a:srgbClr val="323232"/>
+                </a:solidFill>
+              </a:defRPr>
+            </a:pPr>
+            <a:r>
+              <a:t>✅ Key Features:</a:t>
+            </a:r>
+          </a:p>
+          <a:p>
+            <a:pPr>
+              <a:defRPr sz="1800">
+                <a:solidFill>
+                  <a:srgbClr val="323232"/>
+                </a:solidFill>
+              </a:defRPr>
+            </a:pPr>
+            <a:r>
+              <a:t>    • Reliable Data Transfer (RDT) - Sliding Window</a:t>
+            </a:r>
+          </a:p>
+          <a:p>
+            <a:pPr>
+              <a:defRPr sz="1800">
+                <a:solidFill>
+                  <a:srgbClr val="323232"/>
+                </a:solidFill>
+              </a:defRPr>
+            </a:pPr>
+            <a:r>
+              <a:t>    • TCP Reno Congestion Control - Slow Start, AIMD, Fast Recovery</a:t>
+            </a:r>
+          </a:p>
+          <a:p>
+            <a:pPr>
+              <a:defRPr sz="1800">
+                <a:solidFill>
+                  <a:srgbClr val="323232"/>
+                </a:solidFill>
+              </a:defRPr>
+            </a:pPr>
+            <a:r>
+              <a:t>    • Chunk-based Transfer with SHA1 verification</a:t>
+            </a:r>
+          </a:p>
+          <a:p>
+            <a:pPr>
+              <a:defRPr sz="1800">
+                <a:solidFill>
+                  <a:srgbClr val="323232"/>
+                </a:solidFill>
+              </a:defRPr>
+            </a:pPr>
+            <a:r>
+              <a:t>    • Multi-peer Download Support</a:t>
+            </a:r>
+          </a:p>
+          <a:p>
+            <a:pPr>
+              <a:defRPr sz="1800">
+                <a:solidFill>
+                  <a:srgbClr val="323232"/>
+                </a:solidFill>
+              </a:defRPr>
+            </a:pPr>
+            <a:r>
+              <a:t>    • Automatic Crash Recovery</a:t>
             </a:r>
           </a:p>
         </p:txBody>
@@ -4145,14 +5154,57 @@
       <p:grpSpPr/>
       <p:sp>
         <p:nvSpPr>
-          <p:cNvPr id="2" name="TextBox 1"/>
+          <p:cNvPr id="2" name="Rectangle 1"/>
+          <p:cNvSpPr/>
+          <p:nvPr/>
+        </p:nvSpPr>
+        <p:spPr>
+          <a:xfrm>
+            <a:off x="0" y="0"/>
+            <a:ext cx="12191695" cy="914400"/>
+          </a:xfrm>
+          <a:prstGeom prst="rect">
+            <a:avLst/>
+          </a:prstGeom>
+          <a:solidFill>
+            <a:srgbClr val="003366"/>
+          </a:solidFill>
+          <a:ln>
+            <a:noFill/>
+          </a:ln>
+        </p:spPr>
+        <p:style>
+          <a:lnRef idx="1">
+            <a:schemeClr val="accent1"/>
+          </a:lnRef>
+          <a:fillRef idx="3">
+            <a:schemeClr val="accent1"/>
+          </a:fillRef>
+          <a:effectRef idx="2">
+            <a:schemeClr val="accent1"/>
+          </a:effectRef>
+          <a:fontRef idx="minor">
+            <a:schemeClr val="lt1"/>
+          </a:fontRef>
+        </p:style>
+        <p:txBody>
+          <a:bodyPr rtlCol="0" anchor="ctr"/>
+          <a:lstStyle/>
+          <a:p>
+            <a:pPr algn="ctr"/>
+          </a:p>
+        </p:txBody>
+      </p:sp>
+      <p:sp>
+        <p:nvSpPr>
+          <p:cNvPr id="3" name="TextBox 2"/>
           <p:cNvSpPr txBox="1"/>
           <p:nvPr/>
         </p:nvSpPr>
         <p:spPr>
           <a:xfrm>
-            <a:off x="457200" y="274320"/>
-            <a:ext cx="11277295" cy="731520"/>
+            <a:off x="457200" y="182880"/>
+            <a:ext cx="11277295" cy="548640"/>
           </a:xfrm>
           <a:prstGeom prst="rect">
             <a:avLst/>
@@ -4166,7 +5218,11 @@
           <a:lstStyle/>
           <a:p>
             <a:pPr>
-              <a:defRPr sz="3200" b="1"/>
+              <a:defRPr sz="2800" b="1">
+                <a:solidFill>
+                  <a:srgbClr val="FFFFFF"/>
+                </a:solidFill>
+              </a:defRPr>
             </a:pPr>
             <a:r>
               <a:t>Project Structure</a:t>
@@ -4176,7 +5232,7 @@
       </p:sp>
       <p:sp>
         <p:nvSpPr>
-          <p:cNvPr id="3" name="TextBox 2"/>
+          <p:cNvPr id="4" name="TextBox 3"/>
           <p:cNvSpPr txBox="1"/>
           <p:nvPr/>
         </p:nvSpPr>
@@ -4197,84 +5253,128 @@
           <a:lstStyle/>
           <a:p>
             <a:pPr>
-              <a:defRPr sz="2000"/>
-            </a:pPr>
-            <a:r>
-              <a:t>src/packet_utils.py</a:t>
-            </a:r>
-          </a:p>
-          <a:p>
-            <a:pPr>
-              <a:defRPr sz="2000"/>
-            </a:pPr>
-            <a:r>
-              <a:t>  • Protocol: WHOHAS, IHAVE, GET, DATA, ACK, DENIED</a:t>
-            </a:r>
-          </a:p>
-          <a:p>
-            <a:pPr>
-              <a:defRPr sz="2000"/>
-            </a:pPr>
-            <a:r>
-              <a:t>  • Header: Type(1B) + HLen(1B) + PLen(2B) + Seq(4B) + Ack(4B) + Flags(1B)</a:t>
-            </a:r>
-          </a:p>
-          <a:p>
-            <a:pPr>
-              <a:defRPr sz="2000"/>
-            </a:pPr>
-          </a:p>
-          <a:p>
-            <a:pPr>
-              <a:defRPr sz="2000"/>
-            </a:pPr>
-            <a:r>
-              <a:t>src/peer_state.py</a:t>
-            </a:r>
-          </a:p>
-          <a:p>
-            <a:pPr>
-              <a:defRPr sz="2000"/>
-            </a:pPr>
-            <a:r>
-              <a:t>  • TransferSession: RDT + TCP congestion control</a:t>
-            </a:r>
-          </a:p>
-          <a:p>
-            <a:pPr>
-              <a:defRPr sz="2000"/>
-            </a:pPr>
-            <a:r>
-              <a:t>  • PeerState: Peer state management</a:t>
-            </a:r>
-          </a:p>
-          <a:p>
-            <a:pPr>
-              <a:defRPr sz="2000"/>
-            </a:pPr>
-          </a:p>
-          <a:p>
-            <a:pPr>
-              <a:defRPr sz="2000"/>
-            </a:pPr>
-            <a:r>
-              <a:t>src/peer.py</a:t>
-            </a:r>
-          </a:p>
-          <a:p>
-            <a:pPr>
-              <a:defRPr sz="2000"/>
-            </a:pPr>
-            <a:r>
-              <a:t>  • DownloadManager: Multi-chunk orchestration</a:t>
-            </a:r>
-          </a:p>
-          <a:p>
-            <a:pPr>
-              <a:defRPr sz="2000"/>
-            </a:pPr>
-            <a:r>
-              <a:t>  • Event loop with select()</a:t>
+              <a:defRPr sz="1800">
+                <a:solidFill>
+                  <a:srgbClr val="323232"/>
+                </a:solidFill>
+              </a:defRPr>
+            </a:pPr>
+            <a:r>
+              <a:t>📁 src/packet_utils.py</a:t>
+            </a:r>
+          </a:p>
+          <a:p>
+            <a:pPr>
+              <a:defRPr sz="1800">
+                <a:solidFill>
+                  <a:srgbClr val="323232"/>
+                </a:solidFill>
+              </a:defRPr>
+            </a:pPr>
+            <a:r>
+              <a:t>    • Protocol: WHOHAS, IHAVE, GET, DATA, ACK, DENIED</a:t>
+            </a:r>
+          </a:p>
+          <a:p>
+            <a:pPr>
+              <a:defRPr sz="1800">
+                <a:solidFill>
+                  <a:srgbClr val="323232"/>
+                </a:solidFill>
+              </a:defRPr>
+            </a:pPr>
+            <a:r>
+              <a:t>    • Header: Type(1B) + HLen(1B) + PLen(2B) + Seq(4B) + Ack(4B) + Flags(1B)</a:t>
+            </a:r>
+          </a:p>
+          <a:p>
+            <a:pPr>
+              <a:defRPr sz="1800">
+                <a:solidFill>
+                  <a:srgbClr val="323232"/>
+                </a:solidFill>
+              </a:defRPr>
+            </a:pPr>
+          </a:p>
+          <a:p>
+            <a:pPr>
+              <a:defRPr sz="1800">
+                <a:solidFill>
+                  <a:srgbClr val="323232"/>
+                </a:solidFill>
+              </a:defRPr>
+            </a:pPr>
+            <a:r>
+              <a:t>📁 src/peer_state.py</a:t>
+            </a:r>
+          </a:p>
+          <a:p>
+            <a:pPr>
+              <a:defRPr sz="1800">
+                <a:solidFill>
+                  <a:srgbClr val="323232"/>
+                </a:solidFill>
+              </a:defRPr>
+            </a:pPr>
+            <a:r>
+              <a:t>    • TransferSession: RDT + TCP congestion control</a:t>
+            </a:r>
+          </a:p>
+          <a:p>
+            <a:pPr>
+              <a:defRPr sz="1800">
+                <a:solidFill>
+                  <a:srgbClr val="323232"/>
+                </a:solidFill>
+              </a:defRPr>
+            </a:pPr>
+            <a:r>
+              <a:t>    • PeerState: Global peer state management</a:t>
+            </a:r>
+          </a:p>
+          <a:p>
+            <a:pPr>
+              <a:defRPr sz="1800">
+                <a:solidFill>
+                  <a:srgbClr val="323232"/>
+                </a:solidFill>
+              </a:defRPr>
+            </a:pPr>
+          </a:p>
+          <a:p>
+            <a:pPr>
+              <a:defRPr sz="1800">
+                <a:solidFill>
+                  <a:srgbClr val="323232"/>
+                </a:solidFill>
+              </a:defRPr>
+            </a:pPr>
+            <a:r>
+              <a:t>📁 src/peer.py</a:t>
+            </a:r>
+          </a:p>
+          <a:p>
+            <a:pPr>
+              <a:defRPr sz="1800">
+                <a:solidFill>
+                  <a:srgbClr val="323232"/>
+                </a:solidFill>
+              </a:defRPr>
+            </a:pPr>
+            <a:r>
+              <a:t>    • DownloadManager: Multi-chunk orchestration</a:t>
+            </a:r>
+          </a:p>
+          <a:p>
+            <a:pPr>
+              <a:defRPr sz="1800">
+                <a:solidFill>
+                  <a:srgbClr val="323232"/>
+                </a:solidFill>
+              </a:defRPr>
+            </a:pPr>
+            <a:r>
+              <a:t>    • Event loop with select()</a:t>
             </a:r>
           </a:p>
         </p:txBody>
@@ -4299,14 +5399,57 @@
       <p:grpSpPr/>
       <p:sp>
         <p:nvSpPr>
-          <p:cNvPr id="2" name="TextBox 1"/>
+          <p:cNvPr id="2" name="Rectangle 1"/>
+          <p:cNvSpPr/>
+          <p:nvPr/>
+        </p:nvSpPr>
+        <p:spPr>
+          <a:xfrm>
+            <a:off x="0" y="0"/>
+            <a:ext cx="12191695" cy="914400"/>
+          </a:xfrm>
+          <a:prstGeom prst="rect">
+            <a:avLst/>
+          </a:prstGeom>
+          <a:solidFill>
+            <a:srgbClr val="003366"/>
+          </a:solidFill>
+          <a:ln>
+            <a:noFill/>
+          </a:ln>
+        </p:spPr>
+        <p:style>
+          <a:lnRef idx="1">
+            <a:schemeClr val="accent1"/>
+          </a:lnRef>
+          <a:fillRef idx="3">
+            <a:schemeClr val="accent1"/>
+          </a:fillRef>
+          <a:effectRef idx="2">
+            <a:schemeClr val="accent1"/>
+          </a:effectRef>
+          <a:fontRef idx="minor">
+            <a:schemeClr val="lt1"/>
+          </a:fontRef>
+        </p:style>
+        <p:txBody>
+          <a:bodyPr rtlCol="0" anchor="ctr"/>
+          <a:lstStyle/>
+          <a:p>
+            <a:pPr algn="ctr"/>
+          </a:p>
+        </p:txBody>
+      </p:sp>
+      <p:sp>
+        <p:nvSpPr>
+          <p:cNvPr id="3" name="TextBox 2"/>
           <p:cNvSpPr txBox="1"/>
           <p:nvPr/>
         </p:nvSpPr>
         <p:spPr>
           <a:xfrm>
-            <a:off x="457200" y="274320"/>
-            <a:ext cx="11277295" cy="731520"/>
+            <a:off x="457200" y="182880"/>
+            <a:ext cx="11277295" cy="548640"/>
           </a:xfrm>
           <a:prstGeom prst="rect">
             <a:avLst/>
@@ -4320,7 +5463,11 @@
           <a:lstStyle/>
           <a:p>
             <a:pPr>
-              <a:defRPr sz="3200" b="1"/>
+              <a:defRPr sz="2800" b="1">
+                <a:solidFill>
+                  <a:srgbClr val="FFFFFF"/>
+                </a:solidFill>
+              </a:defRPr>
             </a:pPr>
             <a:r>
               <a:t>Protocol Flow</a:t>
@@ -4330,7 +5477,7 @@
       </p:sp>
       <p:sp>
         <p:nvSpPr>
-          <p:cNvPr id="3" name="TextBox 2"/>
+          <p:cNvPr id="4" name="TextBox 3"/>
           <p:cNvSpPr txBox="1"/>
           <p:nvPr/>
         </p:nvSpPr>
@@ -4351,55 +5498,116 @@
           <a:lstStyle/>
           <a:p>
             <a:pPr>
-              <a:defRPr sz="2000"/>
-            </a:pPr>
-            <a:r>
-              <a:t>1. WHOHAS → IHAVE  (Chunk Discovery)</a:t>
-            </a:r>
-          </a:p>
-          <a:p>
-            <a:pPr>
-              <a:defRPr sz="2000"/>
-            </a:pPr>
-            <a:r>
-              <a:t>2. GET → DATA/ACK  (Data Transfer)</a:t>
-            </a:r>
-          </a:p>
-          <a:p>
-            <a:pPr>
-              <a:defRPr sz="2000"/>
-            </a:pPr>
-            <a:r>
-              <a:t>3. Verify SHA1 hash</a:t>
-            </a:r>
-          </a:p>
-          <a:p>
-            <a:pPr>
-              <a:defRPr sz="2000"/>
-            </a:pPr>
-            <a:r>
-              <a:t>4. Save to file</a:t>
-            </a:r>
-          </a:p>
-          <a:p>
-            <a:pPr>
-              <a:defRPr sz="2000"/>
-            </a:pPr>
-          </a:p>
-          <a:p>
-            <a:pPr>
-              <a:defRPr sz="2000"/>
-            </a:pPr>
-            <a:r>
-              <a:t>Header Format: !BBHIIB (13 bytes)</a:t>
-            </a:r>
-          </a:p>
-          <a:p>
-            <a:pPr>
-              <a:defRPr sz="2000"/>
-            </a:pPr>
-            <a:r>
-              <a:t>FLAG_LAST_PACKET = 0x01 (marks last packet)</a:t>
+              <a:defRPr sz="1800">
+                <a:solidFill>
+                  <a:srgbClr val="323232"/>
+                </a:solidFill>
+              </a:defRPr>
+            </a:pPr>
+            <a:r>
+              <a:t>📡 Chunk Discovery:</a:t>
+            </a:r>
+          </a:p>
+          <a:p>
+            <a:pPr>
+              <a:defRPr sz="1800">
+                <a:solidFill>
+                  <a:srgbClr val="323232"/>
+                </a:solidFill>
+              </a:defRPr>
+            </a:pPr>
+            <a:r>
+              <a:t>    1. Sender → Peers: WHOHAS(chunk_hashes)</a:t>
+            </a:r>
+          </a:p>
+          <a:p>
+            <a:pPr>
+              <a:defRPr sz="1800">
+                <a:solidFill>
+                  <a:srgbClr val="323232"/>
+                </a:solidFill>
+              </a:defRPr>
+            </a:pPr>
+            <a:r>
+              <a:t>    2. Peers → Sender: IHAVE(available_chunks)</a:t>
+            </a:r>
+          </a:p>
+          <a:p>
+            <a:pPr>
+              <a:defRPr sz="1800">
+                <a:solidFill>
+                  <a:srgbClr val="323232"/>
+                </a:solidFill>
+              </a:defRPr>
+            </a:pPr>
+          </a:p>
+          <a:p>
+            <a:pPr>
+              <a:defRPr sz="1800">
+                <a:solidFill>
+                  <a:srgbClr val="323232"/>
+                </a:solidFill>
+              </a:defRPr>
+            </a:pPr>
+            <a:r>
+              <a:t>📦 Data Transfer:</a:t>
+            </a:r>
+          </a:p>
+          <a:p>
+            <a:pPr>
+              <a:defRPr sz="1800">
+                <a:solidFill>
+                  <a:srgbClr val="323232"/>
+                </a:solidFill>
+              </a:defRPr>
+            </a:pPr>
+            <a:r>
+              <a:t>    3. Sender → Peer: GET(chunk_hash)</a:t>
+            </a:r>
+          </a:p>
+          <a:p>
+            <a:pPr>
+              <a:defRPr sz="1800">
+                <a:solidFill>
+                  <a:srgbClr val="323232"/>
+                </a:solidFill>
+              </a:defRPr>
+            </a:pPr>
+            <a:r>
+              <a:t>    4. Peer → Sender: DATA(seq, data, is_last)</a:t>
+            </a:r>
+          </a:p>
+          <a:p>
+            <a:pPr>
+              <a:defRPr sz="1800">
+                <a:solidFill>
+                  <a:srgbClr val="323232"/>
+                </a:solidFill>
+              </a:defRPr>
+            </a:pPr>
+            <a:r>
+              <a:t>    5. Sender → Peer: ACK(seq)</a:t>
+            </a:r>
+          </a:p>
+          <a:p>
+            <a:pPr>
+              <a:defRPr sz="1800">
+                <a:solidFill>
+                  <a:srgbClr val="323232"/>
+                </a:solidFill>
+              </a:defRPr>
+            </a:pPr>
+          </a:p>
+          <a:p>
+            <a:pPr>
+              <a:defRPr sz="1800">
+                <a:solidFill>
+                  <a:srgbClr val="323232"/>
+                </a:solidFill>
+              </a:defRPr>
+            </a:pPr>
+            <a:r>
+              <a:t>✅ Completion: Verify SHA1 hash → Save file</a:t>
             </a:r>
           </a:p>
         </p:txBody>
@@ -4424,14 +5632,57 @@
       <p:grpSpPr/>
       <p:sp>
         <p:nvSpPr>
-          <p:cNvPr id="2" name="TextBox 1"/>
+          <p:cNvPr id="2" name="Rectangle 1"/>
+          <p:cNvSpPr/>
+          <p:nvPr/>
+        </p:nvSpPr>
+        <p:spPr>
+          <a:xfrm>
+            <a:off x="0" y="0"/>
+            <a:ext cx="12191695" cy="914400"/>
+          </a:xfrm>
+          <a:prstGeom prst="rect">
+            <a:avLst/>
+          </a:prstGeom>
+          <a:solidFill>
+            <a:srgbClr val="003366"/>
+          </a:solidFill>
+          <a:ln>
+            <a:noFill/>
+          </a:ln>
+        </p:spPr>
+        <p:style>
+          <a:lnRef idx="1">
+            <a:schemeClr val="accent1"/>
+          </a:lnRef>
+          <a:fillRef idx="3">
+            <a:schemeClr val="accent1"/>
+          </a:fillRef>
+          <a:effectRef idx="2">
+            <a:schemeClr val="accent1"/>
+          </a:effectRef>
+          <a:fontRef idx="minor">
+            <a:schemeClr val="lt1"/>
+          </a:fontRef>
+        </p:style>
+        <p:txBody>
+          <a:bodyPr rtlCol="0" anchor="ctr"/>
+          <a:lstStyle/>
+          <a:p>
+            <a:pPr algn="ctr"/>
+          </a:p>
+        </p:txBody>
+      </p:sp>
+      <p:sp>
+        <p:nvSpPr>
+          <p:cNvPr id="3" name="TextBox 2"/>
           <p:cNvSpPr txBox="1"/>
           <p:nvPr/>
         </p:nvSpPr>
         <p:spPr>
           <a:xfrm>
-            <a:off x="457200" y="274320"/>
-            <a:ext cx="11277295" cy="731520"/>
+            <a:off x="457200" y="182880"/>
+            <a:ext cx="11277295" cy="548640"/>
           </a:xfrm>
           <a:prstGeom prst="rect">
             <a:avLst/>
@@ -4445,7 +5696,11 @@
           <a:lstStyle/>
           <a:p>
             <a:pPr>
-              <a:defRPr sz="3200" b="1"/>
+              <a:defRPr sz="2800" b="1">
+                <a:solidFill>
+                  <a:srgbClr val="FFFFFF"/>
+                </a:solidFill>
+              </a:defRPr>
             </a:pPr>
             <a:r>
               <a:t>TCP Reno Congestion Control</a:t>
@@ -4455,7 +5710,7 @@
       </p:sp>
       <p:sp>
         <p:nvSpPr>
-          <p:cNvPr id="3" name="TextBox 2"/>
+          <p:cNvPr id="4" name="TextBox 3"/>
           <p:cNvSpPr txBox="1"/>
           <p:nvPr/>
         </p:nvSpPr>
@@ -4476,71 +5731,116 @@
           <a:lstStyle/>
           <a:p>
             <a:pPr>
-              <a:defRPr sz="2000"/>
-            </a:pPr>
-            <a:r>
-              <a:t>States:</a:t>
-            </a:r>
-          </a:p>
-          <a:p>
-            <a:pPr>
-              <a:defRPr sz="2000"/>
-            </a:pPr>
-            <a:r>
-              <a:t>  • slow_start: cwnd *= 2 each RTT</a:t>
-            </a:r>
-          </a:p>
-          <a:p>
-            <a:pPr>
-              <a:defRPr sz="2000"/>
-            </a:pPr>
-            <a:r>
-              <a:t>  • congestion_avoidance: cwnd += 1/cwnd per ACK</a:t>
-            </a:r>
-          </a:p>
-          <a:p>
-            <a:pPr>
-              <a:defRPr sz="2000"/>
-            </a:pPr>
-            <a:r>
-              <a:t>  • fast_recovery: 3 dup ACKs trigger</a:t>
-            </a:r>
-          </a:p>
-          <a:p>
-            <a:pPr>
-              <a:defRPr sz="2000"/>
-            </a:pPr>
-          </a:p>
-          <a:p>
-            <a:pPr>
-              <a:defRPr sz="2000"/>
-            </a:pPr>
-            <a:r>
-              <a:t>Parameters:</a:t>
-            </a:r>
-          </a:p>
-          <a:p>
-            <a:pPr>
-              <a:defRPr sz="2000"/>
-            </a:pPr>
-            <a:r>
-              <a:t>  • cwnd: Congestion Window (initial = 1)</a:t>
-            </a:r>
-          </a:p>
-          <a:p>
-            <a:pPr>
-              <a:defRPr sz="2000"/>
-            </a:pPr>
-            <a:r>
-              <a:t>  • ssthresh: Slow Start Threshold (initial = 64)</a:t>
-            </a:r>
-          </a:p>
-          <a:p>
-            <a:pPr>
-              <a:defRPr sz="2000"/>
-            </a:pPr>
-            <a:r>
-              <a:t>  • Timeout = EstimatedRTT + 4 * DevRTT</a:t>
+              <a:defRPr sz="1800">
+                <a:solidFill>
+                  <a:srgbClr val="323232"/>
+                </a:solidFill>
+              </a:defRPr>
+            </a:pPr>
+            <a:r>
+              <a:t>🔄 Three States:</a:t>
+            </a:r>
+          </a:p>
+          <a:p>
+            <a:pPr>
+              <a:defRPr sz="1800">
+                <a:solidFill>
+                  <a:srgbClr val="323232"/>
+                </a:solidFill>
+              </a:defRPr>
+            </a:pPr>
+            <a:r>
+              <a:t>    • slow_start: cwnd doubles each RTT</a:t>
+            </a:r>
+          </a:p>
+          <a:p>
+            <a:pPr>
+              <a:defRPr sz="1800">
+                <a:solidFill>
+                  <a:srgbClr val="323232"/>
+                </a:solidFill>
+              </a:defRPr>
+            </a:pPr>
+            <a:r>
+              <a:t>    • congestion_avoidance: cwnd += 1/cwnd per ACK (AIMD)</a:t>
+            </a:r>
+          </a:p>
+          <a:p>
+            <a:pPr>
+              <a:defRPr sz="1800">
+                <a:solidFill>
+                  <a:srgbClr val="323232"/>
+                </a:solidFill>
+              </a:defRPr>
+            </a:pPr>
+            <a:r>
+              <a:t>    • fast_recovery: 3 duplicate ACKs trigger</a:t>
+            </a:r>
+          </a:p>
+          <a:p>
+            <a:pPr>
+              <a:defRPr sz="1800">
+                <a:solidFill>
+                  <a:srgbClr val="323232"/>
+                </a:solidFill>
+              </a:defRPr>
+            </a:pPr>
+          </a:p>
+          <a:p>
+            <a:pPr>
+              <a:defRPr sz="1800">
+                <a:solidFill>
+                  <a:srgbClr val="323232"/>
+                </a:solidFill>
+              </a:defRPr>
+            </a:pPr>
+            <a:r>
+              <a:t>⚙️ Parameters:</a:t>
+            </a:r>
+          </a:p>
+          <a:p>
+            <a:pPr>
+              <a:defRPr sz="1800">
+                <a:solidFill>
+                  <a:srgbClr val="323232"/>
+                </a:solidFill>
+              </a:defRPr>
+            </a:pPr>
+            <a:r>
+              <a:t>    • cwnd: Congestion Window (initial = 1)</a:t>
+            </a:r>
+          </a:p>
+          <a:p>
+            <a:pPr>
+              <a:defRPr sz="1800">
+                <a:solidFill>
+                  <a:srgbClr val="323232"/>
+                </a:solidFill>
+              </a:defRPr>
+            </a:pPr>
+            <a:r>
+              <a:t>    • ssthresh: Slow Start Threshold (initial = 64)</a:t>
+            </a:r>
+          </a:p>
+          <a:p>
+            <a:pPr>
+              <a:defRPr sz="1800">
+                <a:solidFill>
+                  <a:srgbClr val="323232"/>
+                </a:solidFill>
+              </a:defRPr>
+            </a:pPr>
+          </a:p>
+          <a:p>
+            <a:pPr>
+              <a:defRPr sz="1800">
+                <a:solidFill>
+                  <a:srgbClr val="323232"/>
+                </a:solidFill>
+              </a:defRPr>
+            </a:pPr>
+            <a:r>
+              <a:t>⏱️ Timeout = EstimatedRTT + 4 × DevRTT</a:t>
             </a:r>
           </a:p>
         </p:txBody>
@@ -4565,14 +5865,57 @@
       <p:grpSpPr/>
       <p:sp>
         <p:nvSpPr>
-          <p:cNvPr id="2" name="TextBox 1"/>
+          <p:cNvPr id="2" name="Rectangle 1"/>
+          <p:cNvSpPr/>
+          <p:nvPr/>
+        </p:nvSpPr>
+        <p:spPr>
+          <a:xfrm>
+            <a:off x="0" y="0"/>
+            <a:ext cx="12191695" cy="914400"/>
+          </a:xfrm>
+          <a:prstGeom prst="rect">
+            <a:avLst/>
+          </a:prstGeom>
+          <a:solidFill>
+            <a:srgbClr val="003366"/>
+          </a:solidFill>
+          <a:ln>
+            <a:noFill/>
+          </a:ln>
+        </p:spPr>
+        <p:style>
+          <a:lnRef idx="1">
+            <a:schemeClr val="accent1"/>
+          </a:lnRef>
+          <a:fillRef idx="3">
+            <a:schemeClr val="accent1"/>
+          </a:fillRef>
+          <a:effectRef idx="2">
+            <a:schemeClr val="accent1"/>
+          </a:effectRef>
+          <a:fontRef idx="minor">
+            <a:schemeClr val="lt1"/>
+          </a:fontRef>
+        </p:style>
+        <p:txBody>
+          <a:bodyPr rtlCol="0" anchor="ctr"/>
+          <a:lstStyle/>
+          <a:p>
+            <a:pPr algn="ctr"/>
+          </a:p>
+        </p:txBody>
+      </p:sp>
+      <p:sp>
+        <p:nvSpPr>
+          <p:cNvPr id="3" name="TextBox 2"/>
           <p:cNvSpPr txBox="1"/>
           <p:nvPr/>
         </p:nvSpPr>
         <p:spPr>
           <a:xfrm>
-            <a:off x="457200" y="274320"/>
-            <a:ext cx="11277295" cy="731520"/>
+            <a:off x="457200" y="182880"/>
+            <a:ext cx="11277295" cy="548640"/>
           </a:xfrm>
           <a:prstGeom prst="rect">
             <a:avLst/>
@@ -4586,24 +5929,71 @@
           <a:lstStyle/>
           <a:p>
             <a:pPr>
-              <a:defRPr sz="3200" b="1"/>
-            </a:pPr>
-            <a:r>
-              <a:t>Congestion Control Code</a:t>
-            </a:r>
-          </a:p>
-        </p:txBody>
-      </p:sp>
-      <p:sp>
-        <p:nvSpPr>
-          <p:cNvPr id="3" name="TextBox 2"/>
+              <a:defRPr sz="2800" b="1">
+                <a:solidFill>
+                  <a:srgbClr val="FFFFFF"/>
+                </a:solidFill>
+              </a:defRPr>
+            </a:pPr>
+            <a:r>
+              <a:t>Congestion Control - ACK Handling</a:t>
+            </a:r>
+          </a:p>
+        </p:txBody>
+      </p:sp>
+      <p:sp>
+        <p:nvSpPr>
+          <p:cNvPr id="4" name="Rectangle 3"/>
+          <p:cNvSpPr/>
+          <p:nvPr/>
+        </p:nvSpPr>
+        <p:spPr>
+          <a:xfrm>
+            <a:off x="274320" y="1097280"/>
+            <a:ext cx="11643055" cy="5486400"/>
+          </a:xfrm>
+          <a:prstGeom prst="rect">
+            <a:avLst/>
+          </a:prstGeom>
+          <a:solidFill>
+            <a:srgbClr val="282C34"/>
+          </a:solidFill>
+          <a:ln>
+            <a:noFill/>
+          </a:ln>
+        </p:spPr>
+        <p:style>
+          <a:lnRef idx="1">
+            <a:schemeClr val="accent1"/>
+          </a:lnRef>
+          <a:fillRef idx="3">
+            <a:schemeClr val="accent1"/>
+          </a:fillRef>
+          <a:effectRef idx="2">
+            <a:schemeClr val="accent1"/>
+          </a:effectRef>
+          <a:fontRef idx="minor">
+            <a:schemeClr val="lt1"/>
+          </a:fontRef>
+        </p:style>
+        <p:txBody>
+          <a:bodyPr rtlCol="0" anchor="ctr"/>
+          <a:lstStyle/>
+          <a:p>
+            <a:pPr algn="ctr"/>
+          </a:p>
+        </p:txBody>
+      </p:sp>
+      <p:sp>
+        <p:nvSpPr>
+          <p:cNvPr id="5" name="TextBox 4"/>
           <p:cNvSpPr txBox="1"/>
           <p:nvPr/>
         </p:nvSpPr>
         <p:spPr>
           <a:xfrm>
-            <a:off x="457200" y="1188720"/>
-            <a:ext cx="11277295" cy="5212080"/>
+            <a:off x="457200" y="1280160"/>
+            <a:ext cx="11277295" cy="5120640"/>
           </a:xfrm>
           <a:prstGeom prst="rect">
             <a:avLst/>
@@ -4617,7 +6007,12 @@
           <a:lstStyle/>
           <a:p>
             <a:pPr>
-              <a:defRPr sz="2000"/>
+              <a:defRPr sz="1400">
+                <a:solidFill>
+                  <a:srgbClr val="ABB2BF"/>
+                </a:solidFill>
+                <a:latin typeface="Consolas"/>
+              </a:defRPr>
             </a:pPr>
             <a:r>
               <a:t>def on_ack_received(self, ack_seq):</a:t>
@@ -4625,74 +6020,184 @@
           </a:p>
           <a:p>
             <a:pPr>
-              <a:defRPr sz="2000"/>
-            </a:pPr>
-            <a:r>
-              <a:t>    if self.state == 'slow_start':</a:t>
-            </a:r>
-          </a:p>
-          <a:p>
-            <a:pPr>
-              <a:defRPr sz="2000"/>
-            </a:pPr>
-            <a:r>
-              <a:t>        self.cwnd += 1</a:t>
-            </a:r>
-          </a:p>
-          <a:p>
-            <a:pPr>
-              <a:defRPr sz="2000"/>
-            </a:pPr>
-            <a:r>
-              <a:t>        if self.cwnd &gt;= self.ssthresh:</a:t>
-            </a:r>
-          </a:p>
-          <a:p>
-            <a:pPr>
-              <a:defRPr sz="2000"/>
+              <a:defRPr sz="1400">
+                <a:solidFill>
+                  <a:srgbClr val="ABB2BF"/>
+                </a:solidFill>
+                <a:latin typeface="Consolas"/>
+              </a:defRPr>
+            </a:pPr>
+            <a:r>
+              <a:t>    if ack_seq in self.acked_packets:  # Duplicate ACK</a:t>
+            </a:r>
+          </a:p>
+          <a:p>
+            <a:pPr>
+              <a:defRPr sz="1400">
+                <a:solidFill>
+                  <a:srgbClr val="ABB2BF"/>
+                </a:solidFill>
+                <a:latin typeface="Consolas"/>
+              </a:defRPr>
+            </a:pPr>
+            <a:r>
+              <a:t>        self.dup_ack_count += 1</a:t>
+            </a:r>
+          </a:p>
+          <a:p>
+            <a:pPr>
+              <a:defRPr sz="1400">
+                <a:solidFill>
+                  <a:srgbClr val="ABB2BF"/>
+                </a:solidFill>
+                <a:latin typeface="Consolas"/>
+              </a:defRPr>
+            </a:pPr>
+            <a:r>
+              <a:t>        if self.dup_ack_count == 3:</a:t>
+            </a:r>
+          </a:p>
+          <a:p>
+            <a:pPr>
+              <a:defRPr sz="1400">
+                <a:solidFill>
+                  <a:srgbClr val="ABB2BF"/>
+                </a:solidFill>
+                <a:latin typeface="Consolas"/>
+              </a:defRPr>
+            </a:pPr>
+            <a:r>
+              <a:t>            self._enter_fast_recovery()</a:t>
+            </a:r>
+          </a:p>
+          <a:p>
+            <a:pPr>
+              <a:defRPr sz="1400">
+                <a:solidFill>
+                  <a:srgbClr val="ABB2BF"/>
+                </a:solidFill>
+                <a:latin typeface="Consolas"/>
+              </a:defRPr>
+            </a:pPr>
+            <a:r>
+              <a:t>    else:  # New ACK</a:t>
+            </a:r>
+          </a:p>
+          <a:p>
+            <a:pPr>
+              <a:defRPr sz="1400">
+                <a:solidFill>
+                  <a:srgbClr val="ABB2BF"/>
+                </a:solidFill>
+                <a:latin typeface="Consolas"/>
+              </a:defRPr>
+            </a:pPr>
+            <a:r>
+              <a:t>        if self.state == 'slow_start':</a:t>
+            </a:r>
+          </a:p>
+          <a:p>
+            <a:pPr>
+              <a:defRPr sz="1400">
+                <a:solidFill>
+                  <a:srgbClr val="ABB2BF"/>
+                </a:solidFill>
+                <a:latin typeface="Consolas"/>
+              </a:defRPr>
+            </a:pPr>
+            <a:r>
+              <a:t>            self.cwnd += 1</a:t>
+            </a:r>
+          </a:p>
+          <a:p>
+            <a:pPr>
+              <a:defRPr sz="1400">
+                <a:solidFill>
+                  <a:srgbClr val="ABB2BF"/>
+                </a:solidFill>
+                <a:latin typeface="Consolas"/>
+              </a:defRPr>
+            </a:pPr>
+            <a:r>
+              <a:t>            if self.cwnd &gt;= self.ssthresh:</a:t>
+            </a:r>
+          </a:p>
+          <a:p>
+            <a:pPr>
+              <a:defRPr sz="1400">
+                <a:solidFill>
+                  <a:srgbClr val="ABB2BF"/>
+                </a:solidFill>
+                <a:latin typeface="Consolas"/>
+              </a:defRPr>
+            </a:pPr>
+            <a:r>
+              <a:t>                self.state = 'congestion_avoidance'</a:t>
+            </a:r>
+          </a:p>
+          <a:p>
+            <a:pPr>
+              <a:defRPr sz="1400">
+                <a:solidFill>
+                  <a:srgbClr val="ABB2BF"/>
+                </a:solidFill>
+                <a:latin typeface="Consolas"/>
+              </a:defRPr>
+            </a:pPr>
+            <a:r>
+              <a:t>        elif self.state == 'congestion_avoidance':</a:t>
+            </a:r>
+          </a:p>
+          <a:p>
+            <a:pPr>
+              <a:defRPr sz="1400">
+                <a:solidFill>
+                  <a:srgbClr val="ABB2BF"/>
+                </a:solidFill>
+                <a:latin typeface="Consolas"/>
+              </a:defRPr>
+            </a:pPr>
+            <a:r>
+              <a:t>            self.cwnd += 1.0 / self.cwnd  # AIMD</a:t>
+            </a:r>
+          </a:p>
+          <a:p>
+            <a:pPr>
+              <a:defRPr sz="1400">
+                <a:solidFill>
+                  <a:srgbClr val="ABB2BF"/>
+                </a:solidFill>
+                <a:latin typeface="Consolas"/>
+              </a:defRPr>
+            </a:pPr>
+            <a:r>
+              <a:t>        elif self.state == 'fast_recovery':</a:t>
+            </a:r>
+          </a:p>
+          <a:p>
+            <a:pPr>
+              <a:defRPr sz="1400">
+                <a:solidFill>
+                  <a:srgbClr val="ABB2BF"/>
+                </a:solidFill>
+                <a:latin typeface="Consolas"/>
+              </a:defRPr>
+            </a:pPr>
+            <a:r>
+              <a:t>            self.cwnd = self.ssthresh</a:t>
+            </a:r>
+          </a:p>
+          <a:p>
+            <a:pPr>
+              <a:defRPr sz="1400">
+                <a:solidFill>
+                  <a:srgbClr val="ABB2BF"/>
+                </a:solidFill>
+                <a:latin typeface="Consolas"/>
+              </a:defRPr>
             </a:pPr>
             <a:r>
               <a:t>            self.state = 'congestion_avoidance'</a:t>
-            </a:r>
-          </a:p>
-          <a:p>
-            <a:pPr>
-              <a:defRPr sz="2000"/>
-            </a:pPr>
-            <a:r>
-              <a:t>    elif self.state == 'congestion_avoidance':</a:t>
-            </a:r>
-          </a:p>
-          <a:p>
-            <a:pPr>
-              <a:defRPr sz="2000"/>
-            </a:pPr>
-            <a:r>
-              <a:t>        self.cwnd += 1.0 / self.cwnd  # AIMD</a:t>
-            </a:r>
-          </a:p>
-          <a:p>
-            <a:pPr>
-              <a:defRPr sz="2000"/>
-            </a:pPr>
-            <a:r>
-              <a:t>    elif self.state == 'fast_recovery':</a:t>
-            </a:r>
-          </a:p>
-          <a:p>
-            <a:pPr>
-              <a:defRPr sz="2000"/>
-            </a:pPr>
-            <a:r>
-              <a:t>        self.cwnd = self.ssthresh  # Exit fast recovery</a:t>
-            </a:r>
-          </a:p>
-          <a:p>
-            <a:pPr>
-              <a:defRPr sz="2000"/>
-            </a:pPr>
-            <a:r>
-              <a:t>        self.state = 'congestion_avoidance'</a:t>
             </a:r>
           </a:p>
         </p:txBody>
@@ -4717,14 +6222,57 @@
       <p:grpSpPr/>
       <p:sp>
         <p:nvSpPr>
-          <p:cNvPr id="2" name="TextBox 1"/>
+          <p:cNvPr id="2" name="Rectangle 1"/>
+          <p:cNvSpPr/>
+          <p:nvPr/>
+        </p:nvSpPr>
+        <p:spPr>
+          <a:xfrm>
+            <a:off x="0" y="0"/>
+            <a:ext cx="12191695" cy="914400"/>
+          </a:xfrm>
+          <a:prstGeom prst="rect">
+            <a:avLst/>
+          </a:prstGeom>
+          <a:solidFill>
+            <a:srgbClr val="003366"/>
+          </a:solidFill>
+          <a:ln>
+            <a:noFill/>
+          </a:ln>
+        </p:spPr>
+        <p:style>
+          <a:lnRef idx="1">
+            <a:schemeClr val="accent1"/>
+          </a:lnRef>
+          <a:fillRef idx="3">
+            <a:schemeClr val="accent1"/>
+          </a:fillRef>
+          <a:effectRef idx="2">
+            <a:schemeClr val="accent1"/>
+          </a:effectRef>
+          <a:fontRef idx="minor">
+            <a:schemeClr val="lt1"/>
+          </a:fontRef>
+        </p:style>
+        <p:txBody>
+          <a:bodyPr rtlCol="0" anchor="ctr"/>
+          <a:lstStyle/>
+          <a:p>
+            <a:pPr algn="ctr"/>
+          </a:p>
+        </p:txBody>
+      </p:sp>
+      <p:sp>
+        <p:nvSpPr>
+          <p:cNvPr id="3" name="TextBox 2"/>
           <p:cNvSpPr txBox="1"/>
           <p:nvPr/>
         </p:nvSpPr>
         <p:spPr>
           <a:xfrm>
-            <a:off x="457200" y="274320"/>
-            <a:ext cx="11277295" cy="731520"/>
+            <a:off x="457200" y="182880"/>
+            <a:ext cx="11277295" cy="548640"/>
           </a:xfrm>
           <a:prstGeom prst="rect">
             <a:avLst/>
@@ -4738,7 +6286,11 @@
           <a:lstStyle/>
           <a:p>
             <a:pPr>
-              <a:defRPr sz="3200" b="1"/>
+              <a:defRPr sz="2800" b="1">
+                <a:solidFill>
+                  <a:srgbClr val="FFFFFF"/>
+                </a:solidFill>
+              </a:defRPr>
             </a:pPr>
             <a:r>
               <a:t>Fast Recovery &amp; Timeout</a:t>
@@ -4748,14 +6300,57 @@
       </p:sp>
       <p:sp>
         <p:nvSpPr>
-          <p:cNvPr id="3" name="TextBox 2"/>
+          <p:cNvPr id="4" name="Rectangle 3"/>
+          <p:cNvSpPr/>
+          <p:nvPr/>
+        </p:nvSpPr>
+        <p:spPr>
+          <a:xfrm>
+            <a:off x="274320" y="1097280"/>
+            <a:ext cx="11643055" cy="5486400"/>
+          </a:xfrm>
+          <a:prstGeom prst="rect">
+            <a:avLst/>
+          </a:prstGeom>
+          <a:solidFill>
+            <a:srgbClr val="282C34"/>
+          </a:solidFill>
+          <a:ln>
+            <a:noFill/>
+          </a:ln>
+        </p:spPr>
+        <p:style>
+          <a:lnRef idx="1">
+            <a:schemeClr val="accent1"/>
+          </a:lnRef>
+          <a:fillRef idx="3">
+            <a:schemeClr val="accent1"/>
+          </a:fillRef>
+          <a:effectRef idx="2">
+            <a:schemeClr val="accent1"/>
+          </a:effectRef>
+          <a:fontRef idx="minor">
+            <a:schemeClr val="lt1"/>
+          </a:fontRef>
+        </p:style>
+        <p:txBody>
+          <a:bodyPr rtlCol="0" anchor="ctr"/>
+          <a:lstStyle/>
+          <a:p>
+            <a:pPr algn="ctr"/>
+          </a:p>
+        </p:txBody>
+      </p:sp>
+      <p:sp>
+        <p:nvSpPr>
+          <p:cNvPr id="5" name="TextBox 4"/>
           <p:cNvSpPr txBox="1"/>
           <p:nvPr/>
         </p:nvSpPr>
         <p:spPr>
           <a:xfrm>
-            <a:off x="457200" y="1188720"/>
-            <a:ext cx="11277295" cy="5212080"/>
+            <a:off x="457200" y="1280160"/>
+            <a:ext cx="11277295" cy="5120640"/>
           </a:xfrm>
           <a:prstGeom prst="rect">
             <a:avLst/>
@@ -4769,7 +6364,12 @@
           <a:lstStyle/>
           <a:p>
             <a:pPr>
-              <a:defRPr sz="2000"/>
+              <a:defRPr sz="1400">
+                <a:solidFill>
+                  <a:srgbClr val="ABB2BF"/>
+                </a:solidFill>
+                <a:latin typeface="Consolas"/>
+              </a:defRPr>
             </a:pPr>
             <a:r>
               <a:t>def _enter_fast_recovery(self):</a:t>
@@ -4777,23 +6377,38 @@
           </a:p>
           <a:p>
             <a:pPr>
-              <a:defRPr sz="2000"/>
-            </a:pPr>
-            <a:r>
-              <a:t>    self.ssthresh = max(cwnd/2, 2)</a:t>
-            </a:r>
-          </a:p>
-          <a:p>
-            <a:pPr>
-              <a:defRPr sz="2000"/>
-            </a:pPr>
-            <a:r>
-              <a:t>    self.cwnd = ssthresh + 3  # Inflate</a:t>
-            </a:r>
-          </a:p>
-          <a:p>
-            <a:pPr>
-              <a:defRPr sz="2000"/>
+              <a:defRPr sz="1400">
+                <a:solidFill>
+                  <a:srgbClr val="ABB2BF"/>
+                </a:solidFill>
+                <a:latin typeface="Consolas"/>
+              </a:defRPr>
+            </a:pPr>
+            <a:r>
+              <a:t>    self.ssthresh = max(self.cwnd / 2, 2)</a:t>
+            </a:r>
+          </a:p>
+          <a:p>
+            <a:pPr>
+              <a:defRPr sz="1400">
+                <a:solidFill>
+                  <a:srgbClr val="ABB2BF"/>
+                </a:solidFill>
+                <a:latin typeface="Consolas"/>
+              </a:defRPr>
+            </a:pPr>
+            <a:r>
+              <a:t>    self.cwnd = self.ssthresh + 3</a:t>
+            </a:r>
+          </a:p>
+          <a:p>
+            <a:pPr>
+              <a:defRPr sz="1400">
+                <a:solidFill>
+                  <a:srgbClr val="ABB2BF"/>
+                </a:solidFill>
+                <a:latin typeface="Consolas"/>
+              </a:defRPr>
             </a:pPr>
             <a:r>
               <a:t>    self.state = 'fast_recovery'</a:t>
@@ -4801,12 +6416,22 @@
           </a:p>
           <a:p>
             <a:pPr>
-              <a:defRPr sz="2000"/>
-            </a:pPr>
-          </a:p>
-          <a:p>
-            <a:pPr>
-              <a:defRPr sz="2000"/>
+              <a:defRPr sz="1400">
+                <a:solidFill>
+                  <a:srgbClr val="ABB2BF"/>
+                </a:solidFill>
+                <a:latin typeface="Consolas"/>
+              </a:defRPr>
+            </a:pPr>
+          </a:p>
+          <a:p>
+            <a:pPr>
+              <a:defRPr sz="1400">
+                <a:solidFill>
+                  <a:srgbClr val="ABB2BF"/>
+                </a:solidFill>
+                <a:latin typeface="Consolas"/>
+              </a:defRPr>
             </a:pPr>
             <a:r>
               <a:t>def _handle_timeout(self):</a:t>
@@ -4814,26 +6439,77 @@
           </a:p>
           <a:p>
             <a:pPr>
-              <a:defRPr sz="2000"/>
-            </a:pPr>
-            <a:r>
-              <a:t>    self.ssthresh = max(cwnd/2, 2)</a:t>
-            </a:r>
-          </a:p>
-          <a:p>
-            <a:pPr>
-              <a:defRPr sz="2000"/>
-            </a:pPr>
-            <a:r>
-              <a:t>    self.cwnd = 1  # Reset</a:t>
-            </a:r>
-          </a:p>
-          <a:p>
-            <a:pPr>
-              <a:defRPr sz="2000"/>
+              <a:defRPr sz="1400">
+                <a:solidFill>
+                  <a:srgbClr val="ABB2BF"/>
+                </a:solidFill>
+                <a:latin typeface="Consolas"/>
+              </a:defRPr>
+            </a:pPr>
+            <a:r>
+              <a:t>    self.ssthresh = max(self.cwnd / 2, 2)</a:t>
+            </a:r>
+          </a:p>
+          <a:p>
+            <a:pPr>
+              <a:defRPr sz="1400">
+                <a:solidFill>
+                  <a:srgbClr val="ABB2BF"/>
+                </a:solidFill>
+                <a:latin typeface="Consolas"/>
+              </a:defRPr>
+            </a:pPr>
+            <a:r>
+              <a:t>    self.cwnd = 1</a:t>
+            </a:r>
+          </a:p>
+          <a:p>
+            <a:pPr>
+              <a:defRPr sz="1400">
+                <a:solidFill>
+                  <a:srgbClr val="ABB2BF"/>
+                </a:solidFill>
+                <a:latin typeface="Consolas"/>
+              </a:defRPr>
             </a:pPr>
             <a:r>
               <a:t>    self.state = 'slow_start'</a:t>
+            </a:r>
+          </a:p>
+          <a:p>
+            <a:pPr>
+              <a:defRPr sz="1400">
+                <a:solidFill>
+                  <a:srgbClr val="ABB2BF"/>
+                </a:solidFill>
+                <a:latin typeface="Consolas"/>
+              </a:defRPr>
+            </a:pPr>
+            <a:r>
+              <a:t>    self.in_flight = 0</a:t>
+            </a:r>
+          </a:p>
+          <a:p>
+            <a:pPr>
+              <a:defRPr sz="1400">
+                <a:solidFill>
+                  <a:srgbClr val="ABB2BF"/>
+                </a:solidFill>
+                <a:latin typeface="Consolas"/>
+              </a:defRPr>
+            </a:pPr>
+          </a:p>
+          <a:p>
+            <a:pPr>
+              <a:defRPr sz="1400">
+                <a:solidFill>
+                  <a:srgbClr val="ABB2BF"/>
+                </a:solidFill>
+                <a:latin typeface="Consolas"/>
+              </a:defRPr>
+            </a:pPr>
+            <a:r>
+              <a:t># TCP Reno: Fast Recovery avoids slow start on 3 dup ACKs</a:t>
             </a:r>
           </a:p>
         </p:txBody>
@@ -4858,14 +6534,57 @@
       <p:grpSpPr/>
       <p:sp>
         <p:nvSpPr>
-          <p:cNvPr id="2" name="TextBox 1"/>
+          <p:cNvPr id="2" name="Rectangle 1"/>
+          <p:cNvSpPr/>
+          <p:nvPr/>
+        </p:nvSpPr>
+        <p:spPr>
+          <a:xfrm>
+            <a:off x="0" y="0"/>
+            <a:ext cx="12191695" cy="914400"/>
+          </a:xfrm>
+          <a:prstGeom prst="rect">
+            <a:avLst/>
+          </a:prstGeom>
+          <a:solidFill>
+            <a:srgbClr val="003366"/>
+          </a:solidFill>
+          <a:ln>
+            <a:noFill/>
+          </a:ln>
+        </p:spPr>
+        <p:style>
+          <a:lnRef idx="1">
+            <a:schemeClr val="accent1"/>
+          </a:lnRef>
+          <a:fillRef idx="3">
+            <a:schemeClr val="accent1"/>
+          </a:fillRef>
+          <a:effectRef idx="2">
+            <a:schemeClr val="accent1"/>
+          </a:effectRef>
+          <a:fontRef idx="minor">
+            <a:schemeClr val="lt1"/>
+          </a:fontRef>
+        </p:style>
+        <p:txBody>
+          <a:bodyPr rtlCol="0" anchor="ctr"/>
+          <a:lstStyle/>
+          <a:p>
+            <a:pPr algn="ctr"/>
+          </a:p>
+        </p:txBody>
+      </p:sp>
+      <p:sp>
+        <p:nvSpPr>
+          <p:cNvPr id="3" name="TextBox 2"/>
           <p:cNvSpPr txBox="1"/>
           <p:nvPr/>
         </p:nvSpPr>
         <p:spPr>
           <a:xfrm>
-            <a:off x="457200" y="274320"/>
-            <a:ext cx="11277295" cy="731520"/>
+            <a:off x="457200" y="182880"/>
+            <a:ext cx="11277295" cy="548640"/>
           </a:xfrm>
           <a:prstGeom prst="rect">
             <a:avLst/>
@@ -4879,7 +6598,11 @@
           <a:lstStyle/>
           <a:p>
             <a:pPr>
-              <a:defRPr sz="3200" b="1"/>
+              <a:defRPr sz="2800" b="1">
+                <a:solidFill>
+                  <a:srgbClr val="FFFFFF"/>
+                </a:solidFill>
+              </a:defRPr>
             </a:pPr>
             <a:r>
               <a:t>RTT Estimation (RFC 6298)</a:t>
@@ -4889,14 +6612,57 @@
       </p:sp>
       <p:sp>
         <p:nvSpPr>
-          <p:cNvPr id="3" name="TextBox 2"/>
+          <p:cNvPr id="4" name="Rectangle 3"/>
+          <p:cNvSpPr/>
+          <p:nvPr/>
+        </p:nvSpPr>
+        <p:spPr>
+          <a:xfrm>
+            <a:off x="274320" y="1097280"/>
+            <a:ext cx="11643055" cy="5486400"/>
+          </a:xfrm>
+          <a:prstGeom prst="rect">
+            <a:avLst/>
+          </a:prstGeom>
+          <a:solidFill>
+            <a:srgbClr val="282C34"/>
+          </a:solidFill>
+          <a:ln>
+            <a:noFill/>
+          </a:ln>
+        </p:spPr>
+        <p:style>
+          <a:lnRef idx="1">
+            <a:schemeClr val="accent1"/>
+          </a:lnRef>
+          <a:fillRef idx="3">
+            <a:schemeClr val="accent1"/>
+          </a:fillRef>
+          <a:effectRef idx="2">
+            <a:schemeClr val="accent1"/>
+          </a:effectRef>
+          <a:fontRef idx="minor">
+            <a:schemeClr val="lt1"/>
+          </a:fontRef>
+        </p:style>
+        <p:txBody>
+          <a:bodyPr rtlCol="0" anchor="ctr"/>
+          <a:lstStyle/>
+          <a:p>
+            <a:pPr algn="ctr"/>
+          </a:p>
+        </p:txBody>
+      </p:sp>
+      <p:sp>
+        <p:nvSpPr>
+          <p:cNvPr id="5" name="TextBox 4"/>
           <p:cNvSpPr txBox="1"/>
           <p:nvPr/>
         </p:nvSpPr>
         <p:spPr>
           <a:xfrm>
-            <a:off x="457200" y="1188720"/>
-            <a:ext cx="11277295" cy="5212080"/>
+            <a:off x="457200" y="1280160"/>
+            <a:ext cx="11277295" cy="5120640"/>
           </a:xfrm>
           <a:prstGeom prst="rect">
             <a:avLst/>
@@ -4910,57 +6676,162 @@
           <a:lstStyle/>
           <a:p>
             <a:pPr>
-              <a:defRPr sz="2000"/>
-            </a:pPr>
-            <a:r>
-              <a:t>α = 0.125, β = 0.25</a:t>
-            </a:r>
-          </a:p>
-          <a:p>
-            <a:pPr>
-              <a:defRPr sz="2000"/>
-            </a:pPr>
-          </a:p>
-          <a:p>
-            <a:pPr>
-              <a:defRPr sz="2000"/>
-            </a:pPr>
-            <a:r>
-              <a:t>EstimatedRTT = (1-α) * EstimatedRTT + α * SampleRTT</a:t>
-            </a:r>
-          </a:p>
-          <a:p>
-            <a:pPr>
-              <a:defRPr sz="2000"/>
-            </a:pPr>
-            <a:r>
-              <a:t>DevRTT = (1-β) * DevRTT + β * |SampleRTT - EstimatedRTT|</a:t>
-            </a:r>
-          </a:p>
-          <a:p>
-            <a:pPr>
-              <a:defRPr sz="2000"/>
-            </a:pPr>
-          </a:p>
-          <a:p>
-            <a:pPr>
-              <a:defRPr sz="2000"/>
-            </a:pPr>
-            <a:r>
-              <a:t>Timeout = EstimatedRTT + 4 * DevRTT</a:t>
-            </a:r>
-          </a:p>
-          <a:p>
-            <a:pPr>
-              <a:defRPr sz="2000"/>
-            </a:pPr>
-          </a:p>
-          <a:p>
-            <a:pPr>
-              <a:defRPr sz="2000"/>
-            </a:pPr>
-            <a:r>
-              <a:t>Note: Only non-retransmitted packets used for RTT</a:t>
+              <a:defRPr sz="1400">
+                <a:solidFill>
+                  <a:srgbClr val="ABB2BF"/>
+                </a:solidFill>
+                <a:latin typeface="Consolas"/>
+              </a:defRPr>
+            </a:pPr>
+            <a:r>
+              <a:t>def _update_rtt(self, sample_rtt):</a:t>
+            </a:r>
+          </a:p>
+          <a:p>
+            <a:pPr>
+              <a:defRPr sz="1400">
+                <a:solidFill>
+                  <a:srgbClr val="ABB2BF"/>
+                </a:solidFill>
+                <a:latin typeface="Consolas"/>
+              </a:defRPr>
+            </a:pPr>
+            <a:r>
+              <a:t>    alpha, beta = 0.125, 0.25</a:t>
+            </a:r>
+          </a:p>
+          <a:p>
+            <a:pPr>
+              <a:defRPr sz="1400">
+                <a:solidFill>
+                  <a:srgbClr val="ABB2BF"/>
+                </a:solidFill>
+                <a:latin typeface="Consolas"/>
+              </a:defRPr>
+            </a:pPr>
+          </a:p>
+          <a:p>
+            <a:pPr>
+              <a:defRPr sz="1400">
+                <a:solidFill>
+                  <a:srgbClr val="ABB2BF"/>
+                </a:solidFill>
+                <a:latin typeface="Consolas"/>
+              </a:defRPr>
+            </a:pPr>
+            <a:r>
+              <a:t>    if first_sample:</a:t>
+            </a:r>
+          </a:p>
+          <a:p>
+            <a:pPr>
+              <a:defRPr sz="1400">
+                <a:solidFill>
+                  <a:srgbClr val="ABB2BF"/>
+                </a:solidFill>
+                <a:latin typeface="Consolas"/>
+              </a:defRPr>
+            </a:pPr>
+            <a:r>
+              <a:t>        self.estimated_rtt = sample_rtt</a:t>
+            </a:r>
+          </a:p>
+          <a:p>
+            <a:pPr>
+              <a:defRPr sz="1400">
+                <a:solidFill>
+                  <a:srgbClr val="ABB2BF"/>
+                </a:solidFill>
+                <a:latin typeface="Consolas"/>
+              </a:defRPr>
+            </a:pPr>
+            <a:r>
+              <a:t>        self.dev_rtt = sample_rtt / 2</a:t>
+            </a:r>
+          </a:p>
+          <a:p>
+            <a:pPr>
+              <a:defRPr sz="1400">
+                <a:solidFill>
+                  <a:srgbClr val="ABB2BF"/>
+                </a:solidFill>
+                <a:latin typeface="Consolas"/>
+              </a:defRPr>
+            </a:pPr>
+            <a:r>
+              <a:t>    else:</a:t>
+            </a:r>
+          </a:p>
+          <a:p>
+            <a:pPr>
+              <a:defRPr sz="1400">
+                <a:solidFill>
+                  <a:srgbClr val="ABB2BF"/>
+                </a:solidFill>
+                <a:latin typeface="Consolas"/>
+              </a:defRPr>
+            </a:pPr>
+            <a:r>
+              <a:t>        self.estimated_rtt = (1-alpha)*estimated_rtt + alpha*sample_rtt</a:t>
+            </a:r>
+          </a:p>
+          <a:p>
+            <a:pPr>
+              <a:defRPr sz="1400">
+                <a:solidFill>
+                  <a:srgbClr val="ABB2BF"/>
+                </a:solidFill>
+                <a:latin typeface="Consolas"/>
+              </a:defRPr>
+            </a:pPr>
+            <a:r>
+              <a:t>        self.dev_rtt = (1-beta)*dev_rtt + beta*|sample_rtt - estimated_rtt|</a:t>
+            </a:r>
+          </a:p>
+          <a:p>
+            <a:pPr>
+              <a:defRPr sz="1400">
+                <a:solidFill>
+                  <a:srgbClr val="ABB2BF"/>
+                </a:solidFill>
+                <a:latin typeface="Consolas"/>
+              </a:defRPr>
+            </a:pPr>
+          </a:p>
+          <a:p>
+            <a:pPr>
+              <a:defRPr sz="1400">
+                <a:solidFill>
+                  <a:srgbClr val="ABB2BF"/>
+                </a:solidFill>
+                <a:latin typeface="Consolas"/>
+              </a:defRPr>
+            </a:pPr>
+            <a:r>
+              <a:t>    self.timeout_interval = estimated_rtt + 4 * dev_rtt</a:t>
+            </a:r>
+          </a:p>
+          <a:p>
+            <a:pPr>
+              <a:defRPr sz="1400">
+                <a:solidFill>
+                  <a:srgbClr val="ABB2BF"/>
+                </a:solidFill>
+                <a:latin typeface="Consolas"/>
+              </a:defRPr>
+            </a:pPr>
+          </a:p>
+          <a:p>
+            <a:pPr>
+              <a:defRPr sz="1400">
+                <a:solidFill>
+                  <a:srgbClr val="ABB2BF"/>
+                </a:solidFill>
+                <a:latin typeface="Consolas"/>
+              </a:defRPr>
+            </a:pPr>
+            <a:r>
+              <a:t># Only non-retransmitted packets used for RTT</a:t>
             </a:r>
           </a:p>
         </p:txBody>
@@ -4985,14 +6856,57 @@
       <p:grpSpPr/>
       <p:sp>
         <p:nvSpPr>
-          <p:cNvPr id="2" name="TextBox 1"/>
+          <p:cNvPr id="2" name="Rectangle 1"/>
+          <p:cNvSpPr/>
+          <p:nvPr/>
+        </p:nvSpPr>
+        <p:spPr>
+          <a:xfrm>
+            <a:off x="0" y="0"/>
+            <a:ext cx="12191695" cy="914400"/>
+          </a:xfrm>
+          <a:prstGeom prst="rect">
+            <a:avLst/>
+          </a:prstGeom>
+          <a:solidFill>
+            <a:srgbClr val="003366"/>
+          </a:solidFill>
+          <a:ln>
+            <a:noFill/>
+          </a:ln>
+        </p:spPr>
+        <p:style>
+          <a:lnRef idx="1">
+            <a:schemeClr val="accent1"/>
+          </a:lnRef>
+          <a:fillRef idx="3">
+            <a:schemeClr val="accent1"/>
+          </a:fillRef>
+          <a:effectRef idx="2">
+            <a:schemeClr val="accent1"/>
+          </a:effectRef>
+          <a:fontRef idx="minor">
+            <a:schemeClr val="lt1"/>
+          </a:fontRef>
+        </p:style>
+        <p:txBody>
+          <a:bodyPr rtlCol="0" anchor="ctr"/>
+          <a:lstStyle/>
+          <a:p>
+            <a:pPr algn="ctr"/>
+          </a:p>
+        </p:txBody>
+      </p:sp>
+      <p:sp>
+        <p:nvSpPr>
+          <p:cNvPr id="3" name="TextBox 2"/>
           <p:cNvSpPr txBox="1"/>
           <p:nvPr/>
         </p:nvSpPr>
         <p:spPr>
           <a:xfrm>
-            <a:off x="457200" y="274320"/>
-            <a:ext cx="11277295" cy="731520"/>
+            <a:off x="457200" y="182880"/>
+            <a:ext cx="11277295" cy="548640"/>
           </a:xfrm>
           <a:prstGeom prst="rect">
             <a:avLst/>
@@ -5006,24 +6920,73 @@
           <a:lstStyle/>
           <a:p>
             <a:pPr>
-              <a:defRPr sz="3200" b="1"/>
-            </a:pPr>
-            <a:r>
-              <a:t>Cwnd Plot Description</a:t>
-            </a:r>
-          </a:p>
-        </p:txBody>
-      </p:sp>
-      <p:sp>
-        <p:nvSpPr>
-          <p:cNvPr id="3" name="TextBox 2"/>
+              <a:defRPr sz="2800" b="1">
+                <a:solidFill>
+                  <a:srgbClr val="FFFFFF"/>
+                </a:solidFill>
+              </a:defRPr>
+            </a:pPr>
+            <a:r>
+              <a:t>Congestion Control Visualization</a:t>
+            </a:r>
+          </a:p>
+        </p:txBody>
+      </p:sp>
+      <p:sp>
+        <p:nvSpPr>
+          <p:cNvPr id="4" name="Rectangle 3"/>
+          <p:cNvSpPr/>
+          <p:nvPr/>
+        </p:nvSpPr>
+        <p:spPr>
+          <a:xfrm>
+            <a:off x="457200" y="1188720"/>
+            <a:ext cx="11277295" cy="3657600"/>
+          </a:xfrm>
+          <a:prstGeom prst="rect">
+            <a:avLst/>
+          </a:prstGeom>
+          <a:solidFill>
+            <a:srgbClr val="FFFACD"/>
+          </a:solidFill>
+          <a:ln w="38100">
+            <a:solidFill>
+              <a:srgbClr val="FFC800"/>
+            </a:solidFill>
+          </a:ln>
+        </p:spPr>
+        <p:style>
+          <a:lnRef idx="1">
+            <a:schemeClr val="accent1"/>
+          </a:lnRef>
+          <a:fillRef idx="3">
+            <a:schemeClr val="accent1"/>
+          </a:fillRef>
+          <a:effectRef idx="2">
+            <a:schemeClr val="accent1"/>
+          </a:effectRef>
+          <a:fontRef idx="minor">
+            <a:schemeClr val="lt1"/>
+          </a:fontRef>
+        </p:style>
+        <p:txBody>
+          <a:bodyPr rtlCol="0" anchor="ctr"/>
+          <a:lstStyle/>
+          <a:p>
+            <a:pPr algn="ctr"/>
+          </a:p>
+        </p:txBody>
+      </p:sp>
+      <p:sp>
+        <p:nvSpPr>
+          <p:cNvPr id="5" name="TextBox 4"/>
           <p:cNvSpPr txBox="1"/>
           <p:nvPr/>
         </p:nvSpPr>
         <p:spPr>
           <a:xfrm>
-            <a:off x="457200" y="1188720"/>
-            <a:ext cx="11277295" cy="5212080"/>
+            <a:off x="914400" y="2286000"/>
+            <a:ext cx="10362895" cy="1828800"/>
           </a:xfrm>
           <a:prstGeom prst="rect">
             <a:avLst/>
@@ -5031,74 +6994,79 @@
           <a:noFill/>
         </p:spPr>
         <p:txBody>
+          <a:bodyPr wrap="none">
+            <a:spAutoFit/>
+          </a:bodyPr>
+          <a:lstStyle/>
+          <a:p>
+            <a:pPr algn="ctr">
+              <a:defRPr sz="2800">
+                <a:solidFill>
+                  <a:srgbClr val="966400"/>
+                </a:solidFill>
+              </a:defRPr>
+            </a:pPr>
+            <a:r>
+              <a:t>📊 INSERT CWND PLOT HERE</a:t>
+            </a:r>
+          </a:p>
+        </p:txBody>
+      </p:sp>
+      <p:sp>
+        <p:nvSpPr>
+          <p:cNvPr id="6" name="TextBox 5"/>
+          <p:cNvSpPr txBox="1"/>
+          <p:nvPr/>
+        </p:nvSpPr>
+        <p:spPr>
+          <a:xfrm>
+            <a:off x="457200" y="5029200"/>
+            <a:ext cx="11277295" cy="1371600"/>
+          </a:xfrm>
+          <a:prstGeom prst="rect">
+            <a:avLst/>
+          </a:prstGeom>
+          <a:noFill/>
+        </p:spPr>
+        <p:txBody>
           <a:bodyPr wrap="square">
             <a:spAutoFit/>
           </a:bodyPr>
           <a:lstStyle/>
           <a:p>
             <a:pPr>
-              <a:defRPr sz="2000"/>
-            </a:pPr>
-            <a:r>
-              <a:t>Expected behavior:</a:t>
-            </a:r>
-          </a:p>
-          <a:p>
-            <a:pPr>
-              <a:defRPr sz="2000"/>
-            </a:pPr>
-          </a:p>
-          <a:p>
-            <a:pPr>
-              <a:defRPr sz="2000"/>
-            </a:pPr>
-            <a:r>
-              <a:t>• Slow Start: Exponential growth (1→2→4→8→...)</a:t>
-            </a:r>
-          </a:p>
-          <a:p>
-            <a:pPr>
-              <a:defRPr sz="2000"/>
-            </a:pPr>
-            <a:r>
-              <a:t>• cwnd &gt;= ssthresh: Enter congestion avoidance</a:t>
-            </a:r>
-          </a:p>
-          <a:p>
-            <a:pPr>
-              <a:defRPr sz="2000"/>
-            </a:pPr>
-            <a:r>
-              <a:t>• Congestion Avoidance: Linear growth</a:t>
-            </a:r>
-          </a:p>
-          <a:p>
-            <a:pPr>
-              <a:defRPr sz="2000"/>
-            </a:pPr>
-            <a:r>
-              <a:t>• 3 Dup ACKs: Fast Recovery (ssthresh=cwnd/2, cwnd=ssthresh+3)</a:t>
-            </a:r>
-          </a:p>
-          <a:p>
-            <a:pPr>
-              <a:defRPr sz="2000"/>
-            </a:pPr>
-            <a:r>
-              <a:t>• Timeout: Back to slow start (cwnd=1)</a:t>
-            </a:r>
-          </a:p>
-          <a:p>
-            <a:pPr>
-              <a:defRPr sz="2000"/>
-            </a:pPr>
-          </a:p>
-          <a:p>
-            <a:pPr>
-              <a:defRPr sz="2000"/>
-            </a:pPr>
-            <a:r>
-              <a:t>[Insert cwnd plot here]</a:t>
+              <a:defRPr sz="1400" i="1">
+                <a:solidFill>
+                  <a:srgbClr val="646464"/>
+                </a:solidFill>
+              </a:defRPr>
+            </a:pPr>
+            <a:r>
+              <a:t>💡 Record cwnd values during transfer and plot</a:t>
+            </a:r>
+          </a:p>
+          <a:p>
+            <a:pPr>
+              <a:defRPr sz="1400" i="1">
+                <a:solidFill>
+                  <a:srgbClr val="646464"/>
+                </a:solidFill>
+              </a:defRPr>
+            </a:pPr>
+            <a:r>
+              <a:t>💡 Show: Slow Start → Congestion Avoidance → Fast Recovery</a:t>
+            </a:r>
+          </a:p>
+          <a:p>
+            <a:pPr>
+              <a:defRPr sz="1400" i="1">
+                <a:solidFill>
+                  <a:srgbClr val="646464"/>
+                </a:solidFill>
+              </a:defRPr>
+            </a:pPr>
+            <a:r>
+              <a:t>💡 Label state transitions on the plot</a:t>
             </a:r>
           </a:p>
         </p:txBody>

</xml_diff>

<commit_message>
Convert presentation.pptx to Chinese
Co-authored-by: wuzhi456 <217564920+wuzhi456@users.noreply.github.com>
</commit_message>
<xml_diff>
--- a/presentation.pptx
+++ b/presentation.pptx
@@ -3176,7 +3176,7 @@
               </a:defRPr>
             </a:pPr>
             <a:r>
-              <a:t>CS305 P2P File Transfer System</a:t>
+              <a:t>CS305 P2P 文件传输系统</a:t>
             </a:r>
           </a:p>
         </p:txBody>
@@ -3211,7 +3211,7 @@
               </a:defRPr>
             </a:pPr>
             <a:r>
-              <a:t>UDP-based RDT with TCP Reno Congestion Control</a:t>
+              <a:t>基于UDP的可靠数据传输 + TCP Reno拥塞控制</a:t>
             </a:r>
           </a:p>
         </p:txBody>
@@ -3307,7 +3307,7 @@
               </a:defRPr>
             </a:pPr>
             <a:r>
-              <a:t>Out-of-Order Handling</a:t>
+              <a:t>乱序包处理</a:t>
             </a:r>
           </a:p>
         </p:txBody>
@@ -3399,7 +3399,7 @@
               </a:defRPr>
             </a:pPr>
             <a:r>
-              <a:t>    if seq == self.next_seq:  # In-order</a:t>
+              <a:t>    if seq == self.next_seq:  # 按序到达</a:t>
             </a:r>
           </a:p>
           <a:p>
@@ -3448,6 +3448,19 @@
               </a:defRPr>
             </a:pPr>
             <a:r>
+              <a:t>        # 从缓冲区取出连续的包</a:t>
+            </a:r>
+          </a:p>
+          <a:p>
+            <a:pPr>
+              <a:defRPr sz="1400">
+                <a:solidFill>
+                  <a:srgbClr val="ABB2BF"/>
+                </a:solidFill>
+                <a:latin typeface="Consolas"/>
+              </a:defRPr>
+            </a:pPr>
+            <a:r>
               <a:t>        while self.next_seq in self.out_of_order_buffer:</a:t>
             </a:r>
           </a:p>
@@ -3500,7 +3513,7 @@
               </a:defRPr>
             </a:pPr>
             <a:r>
-              <a:t>    else:  # Out-of-order</a:t>
+              <a:t>    else:  # 乱序到达，缓存</a:t>
             </a:r>
           </a:p>
           <a:p>
@@ -3609,7 +3622,7 @@
               </a:defRPr>
             </a:pPr>
             <a:r>
-              <a:t>Crash Recovery</a:t>
+              <a:t>崩溃恢复机制</a:t>
             </a:r>
           </a:p>
         </p:txBody>
@@ -3644,7 +3657,7 @@
               </a:defRPr>
             </a:pPr>
             <a:r>
-              <a:t>🔍 Detection:</a:t>
+              <a:t>🔍 检测机制：</a:t>
             </a:r>
           </a:p>
           <a:p>
@@ -3656,7 +3669,7 @@
               </a:defRPr>
             </a:pPr>
             <a:r>
-              <a:t>    • Monitor last_activity time</a:t>
+              <a:t>    • 监控 last_activity 时间</a:t>
             </a:r>
           </a:p>
           <a:p>
@@ -3668,7 +3681,7 @@
               </a:defRPr>
             </a:pPr>
             <a:r>
-              <a:t>    • 8s warning → 12s crash detection</a:t>
+              <a:t>    • 8秒警告 → 12秒判定崩溃</a:t>
             </a:r>
           </a:p>
           <a:p>
@@ -3689,7 +3702,7 @@
               </a:defRPr>
             </a:pPr>
             <a:r>
-              <a:t>🔄 Recovery:</a:t>
+              <a:t>🔄 恢复流程：</a:t>
             </a:r>
           </a:p>
           <a:p>
@@ -3701,7 +3714,7 @@
               </a:defRPr>
             </a:pPr>
             <a:r>
-              <a:t>    • Mark peer as suspected</a:t>
+              <a:t>    • 将Peer标记为可疑</a:t>
             </a:r>
           </a:p>
           <a:p>
@@ -3713,7 +3726,7 @@
               </a:defRPr>
             </a:pPr>
             <a:r>
-              <a:t>    • Find alternative peer</a:t>
+              <a:t>    • 从 chunk_sources 中查找备选Peer</a:t>
             </a:r>
           </a:p>
           <a:p>
@@ -3725,7 +3738,7 @@
               </a:defRPr>
             </a:pPr>
             <a:r>
-              <a:t>    • Restart download</a:t>
+              <a:t>    • 从新Peer重新开始下载</a:t>
             </a:r>
           </a:p>
           <a:p>
@@ -3746,7 +3759,7 @@
               </a:defRPr>
             </a:pPr>
             <a:r>
-              <a:t>⚙️ Parameters:</a:t>
+              <a:t>⚙️ 相关参数：</a:t>
             </a:r>
           </a:p>
           <a:p>
@@ -3758,7 +3771,7 @@
               </a:defRPr>
             </a:pPr>
             <a:r>
-              <a:t>    • peer_retry_delay: 5s</a:t>
+              <a:t>    • peer_retry_delay：5秒</a:t>
             </a:r>
           </a:p>
           <a:p>
@@ -3770,7 +3783,7 @@
               </a:defRPr>
             </a:pPr>
             <a:r>
-              <a:t>    • max_attempts: 5 per chunk</a:t>
+              <a:t>    • max_attempts：每个chunk最多重试5次</a:t>
             </a:r>
           </a:p>
         </p:txBody>
@@ -3866,7 +3879,7 @@
               </a:defRPr>
             </a:pPr>
             <a:r>
-              <a:t>Concurrency Visualization</a:t>
+              <a:t>并发测试可视化</a:t>
             </a:r>
           </a:p>
         </p:txBody>
@@ -3946,7 +3959,7 @@
               </a:defRPr>
             </a:pPr>
             <a:r>
-              <a:t>📊 INSERT CONCURRENCY PLOT HERE</a:t>
+              <a:t>📊 在此处插入并发测试图</a:t>
             </a:r>
           </a:p>
         </p:txBody>
@@ -3981,7 +3994,7 @@
               </a:defRPr>
             </a:pPr>
             <a:r>
-              <a:t>💡 Run: python3 test/concurrency_visualizer.py logs/peer1.log</a:t>
+              <a:t>💡 运行命令：python3 test/concurrency_visualizer.py logs/peer1.log</a:t>
             </a:r>
           </a:p>
           <a:p>
@@ -3993,7 +4006,7 @@
               </a:defRPr>
             </a:pPr>
             <a:r>
-              <a:t>💡 Shows parallel downloads from multiple peers</a:t>
+              <a:t>💡 展示多个Peer并行下载的情况</a:t>
             </a:r>
           </a:p>
         </p:txBody>
@@ -4089,7 +4102,7 @@
               </a:defRPr>
             </a:pPr>
             <a:r>
-              <a:t>Crash Recovery Test</a:t>
+              <a:t>崩溃恢复测试</a:t>
             </a:r>
           </a:p>
         </p:txBody>
@@ -4169,7 +4182,7 @@
               </a:defRPr>
             </a:pPr>
             <a:r>
-              <a:t>📊 INSERT CRASH TEST PLOT HERE</a:t>
+              <a:t>📊 在此处插入崩溃测试图</a:t>
             </a:r>
           </a:p>
         </p:txBody>
@@ -4204,7 +4217,7 @@
               </a:defRPr>
             </a:pPr>
             <a:r>
-              <a:t>💡 Run: python3 test/concurrency_visualizer.py logs/peer1.log</a:t>
+              <a:t>💡 运行崩溃测试后执行：python3 test/concurrency_visualizer.py logs/peer1.log</a:t>
             </a:r>
           </a:p>
           <a:p>
@@ -4216,7 +4229,7 @@
               </a:defRPr>
             </a:pPr>
             <a:r>
-              <a:t>💡 Run after crash test to show peer failover</a:t>
+              <a:t>💡 展示Peer崩溃后自动切换到其他Peer的过程</a:t>
             </a:r>
           </a:p>
         </p:txBody>
@@ -4312,7 +4325,7 @@
               </a:defRPr>
             </a:pPr>
             <a:r>
-              <a:t>Optimizations</a:t>
+              <a:t>实现的优化</a:t>
             </a:r>
           </a:p>
         </p:txBody>
@@ -4347,7 +4360,7 @@
               </a:defRPr>
             </a:pPr>
             <a:r>
-              <a:t>🚀 TCP Reno (vs Tahoe):</a:t>
+              <a:t>🚀 TCP Reno（相比Tahoe）：</a:t>
             </a:r>
           </a:p>
           <a:p>
@@ -4359,7 +4372,7 @@
               </a:defRPr>
             </a:pPr>
             <a:r>
-              <a:t>    • Fast Recovery on 3 dup ACKs</a:t>
+              <a:t>    • 3个重复ACK触发快速恢复，避免回到慢启动</a:t>
             </a:r>
           </a:p>
           <a:p>
@@ -4380,7 +4393,7 @@
               </a:defRPr>
             </a:pPr>
             <a:r>
-              <a:t>📦 Selective Repeat:</a:t>
+              <a:t>📦 选择性重复元素：</a:t>
             </a:r>
           </a:p>
           <a:p>
@@ -4392,7 +4405,7 @@
               </a:defRPr>
             </a:pPr>
             <a:r>
-              <a:t>    • Out-of-order packet buffering</a:t>
+              <a:t>    • 乱序包缓存</a:t>
             </a:r>
           </a:p>
           <a:p>
@@ -4413,7 +4426,7 @@
               </a:defRPr>
             </a:pPr>
             <a:r>
-              <a:t>💪 Crash Recovery:</a:t>
+              <a:t>💪 崩溃恢复：</a:t>
             </a:r>
           </a:p>
           <a:p>
@@ -4425,7 +4438,7 @@
               </a:defRPr>
             </a:pPr>
             <a:r>
-              <a:t>    • Automatic peer failover</a:t>
+              <a:t>    • 自动切换到其他Peer</a:t>
             </a:r>
           </a:p>
           <a:p>
@@ -4446,7 +4459,7 @@
               </a:defRPr>
             </a:pPr>
             <a:r>
-              <a:t>⏱️ Dynamic Timeout:</a:t>
+              <a:t>⏱️ 动态超时：</a:t>
             </a:r>
           </a:p>
           <a:p>
@@ -4458,7 +4471,7 @@
               </a:defRPr>
             </a:pPr>
             <a:r>
-              <a:t>    • RFC 6298 RTT estimation</a:t>
+              <a:t>    • 基于RFC 6298的RTT估计</a:t>
             </a:r>
           </a:p>
         </p:txBody>
@@ -4554,7 +4567,7 @@
               </a:defRPr>
             </a:pPr>
             <a:r>
-              <a:t>Summary</a:t>
+              <a:t>总结</a:t>
             </a:r>
           </a:p>
         </p:txBody>
@@ -4589,7 +4602,7 @@
               </a:defRPr>
             </a:pPr>
             <a:r>
-              <a:t>✅ Implemented:</a:t>
+              <a:t>✅ 已实现功能：</a:t>
             </a:r>
           </a:p>
           <a:p>
@@ -4601,7 +4614,7 @@
               </a:defRPr>
             </a:pPr>
             <a:r>
-              <a:t>    • Reliable Data Transfer over UDP</a:t>
+              <a:t>    • 基于UDP的可靠数据传输</a:t>
             </a:r>
           </a:p>
           <a:p>
@@ -4613,7 +4626,7 @@
               </a:defRPr>
             </a:pPr>
             <a:r>
-              <a:t>    • TCP Reno Congestion Control</a:t>
+              <a:t>    • TCP Reno 拥塞控制</a:t>
             </a:r>
           </a:p>
           <a:p>
@@ -4625,7 +4638,7 @@
               </a:defRPr>
             </a:pPr>
             <a:r>
-              <a:t>    • Out-of-order Handling</a:t>
+              <a:t>    • 乱序包处理</a:t>
             </a:r>
           </a:p>
           <a:p>
@@ -4637,7 +4650,7 @@
               </a:defRPr>
             </a:pPr>
             <a:r>
-              <a:t>    • Multi-peer Download</a:t>
+              <a:t>    • 多源并行下载</a:t>
             </a:r>
           </a:p>
           <a:p>
@@ -4649,7 +4662,7 @@
               </a:defRPr>
             </a:pPr>
             <a:r>
-              <a:t>    • Crash Recovery</a:t>
+              <a:t>    • 自动崩溃恢复</a:t>
             </a:r>
           </a:p>
           <a:p>
@@ -4670,7 +4683,7 @@
               </a:defRPr>
             </a:pPr>
             <a:r>
-              <a:t>🏗️ Key Classes:</a:t>
+              <a:t>🏗️ 核心类：</a:t>
             </a:r>
           </a:p>
           <a:p>
@@ -4682,7 +4695,31 @@
               </a:defRPr>
             </a:pPr>
             <a:r>
-              <a:t>    • TransferSession, PeerState, DownloadManager</a:t>
+              <a:t>    • TransferSession：传输会话管理</a:t>
+            </a:r>
+          </a:p>
+          <a:p>
+            <a:pPr>
+              <a:defRPr sz="1800">
+                <a:solidFill>
+                  <a:srgbClr val="323232"/>
+                </a:solidFill>
+              </a:defRPr>
+            </a:pPr>
+            <a:r>
+              <a:t>    • PeerState：Peer状态管理</a:t>
+            </a:r>
+          </a:p>
+          <a:p>
+            <a:pPr>
+              <a:defRPr sz="1800">
+                <a:solidFill>
+                  <a:srgbClr val="323232"/>
+                </a:solidFill>
+              </a:defRPr>
+            </a:pPr>
+            <a:r>
+              <a:t>    • DownloadManager：下载调度</a:t>
             </a:r>
           </a:p>
         </p:txBody>
@@ -4778,7 +4815,7 @@
               </a:defRPr>
             </a:pPr>
             <a:r>
-              <a:t>Contribution Rate</a:t>
+              <a:t>贡献比例</a:t>
             </a:r>
           </a:p>
         </p:txBody>
@@ -4858,7 +4895,7 @@
               </a:defRPr>
             </a:pPr>
             <a:r>
-              <a:t>📝 FILL IN TEAM CONTRIBUTIONS</a:t>
+              <a:t>📝 在此处填写团队成员贡献</a:t>
             </a:r>
           </a:p>
         </p:txBody>
@@ -4893,7 +4930,7 @@
               </a:defRPr>
             </a:pPr>
             <a:r>
-              <a:t>💡 List each member and percentage</a:t>
+              <a:t>💡 列出每位成员及其贡献百分比</a:t>
             </a:r>
           </a:p>
           <a:p>
@@ -4905,7 +4942,7 @@
               </a:defRPr>
             </a:pPr>
             <a:r>
-              <a:t>💡 Example: Member A: 50%, Member B: 50%</a:t>
+              <a:t>💡 示例：成员A: 50%, 成员B: 50%</a:t>
             </a:r>
           </a:p>
           <a:p>
@@ -4917,7 +4954,7 @@
               </a:defRPr>
             </a:pPr>
             <a:r>
-              <a:t>💡 Must sum to 100%</a:t>
+              <a:t>💡 所有成员贡献之和必须等于100%</a:t>
             </a:r>
           </a:p>
         </p:txBody>
@@ -5013,7 +5050,7 @@
               </a:defRPr>
             </a:pPr>
             <a:r>
-              <a:t>Project Overview</a:t>
+              <a:t>项目概述</a:t>
             </a:r>
           </a:p>
         </p:txBody>
@@ -5048,7 +5085,7 @@
               </a:defRPr>
             </a:pPr>
             <a:r>
-              <a:t>🎯 Goal: Reliable file transfer over unreliable UDP</a:t>
+              <a:t>🎯 目标：在不可靠的UDP上实现可靠文件传输</a:t>
             </a:r>
           </a:p>
           <a:p>
@@ -5069,7 +5106,7 @@
               </a:defRPr>
             </a:pPr>
             <a:r>
-              <a:t>✅ Key Features:</a:t>
+              <a:t>✅ 实现的核心功能：</a:t>
             </a:r>
           </a:p>
           <a:p>
@@ -5081,7 +5118,7 @@
               </a:defRPr>
             </a:pPr>
             <a:r>
-              <a:t>    • Reliable Data Transfer (RDT) - Sliding Window</a:t>
+              <a:t>    • 可靠数据传输 (RDT) - 滑动窗口协议</a:t>
             </a:r>
           </a:p>
           <a:p>
@@ -5093,7 +5130,7 @@
               </a:defRPr>
             </a:pPr>
             <a:r>
-              <a:t>    • TCP Reno Congestion Control - Slow Start, AIMD, Fast Recovery</a:t>
+              <a:t>    • TCP Reno 拥塞控制 - 慢启动、AIMD、快速恢复</a:t>
             </a:r>
           </a:p>
           <a:p>
@@ -5105,7 +5142,7 @@
               </a:defRPr>
             </a:pPr>
             <a:r>
-              <a:t>    • Chunk-based Transfer with SHA1 verification</a:t>
+              <a:t>    • 基于 Chunk 的传输 - 文件分块 + SHA1 校验</a:t>
             </a:r>
           </a:p>
           <a:p>
@@ -5117,7 +5154,7 @@
               </a:defRPr>
             </a:pPr>
             <a:r>
-              <a:t>    • Multi-peer Download Support</a:t>
+              <a:t>    • 多源并行下载 - 支持从多个 Peer 同时下载</a:t>
             </a:r>
           </a:p>
           <a:p>
@@ -5129,7 +5166,7 @@
               </a:defRPr>
             </a:pPr>
             <a:r>
-              <a:t>    • Automatic Crash Recovery</a:t>
+              <a:t>    • 自动崩溃恢复 - Peer 崩溃时自动切换</a:t>
             </a:r>
           </a:p>
         </p:txBody>
@@ -5225,7 +5262,7 @@
               </a:defRPr>
             </a:pPr>
             <a:r>
-              <a:t>Project Structure</a:t>
+              <a:t>项目结构</a:t>
             </a:r>
           </a:p>
         </p:txBody>
@@ -5272,7 +5309,7 @@
               </a:defRPr>
             </a:pPr>
             <a:r>
-              <a:t>    • Protocol: WHOHAS, IHAVE, GET, DATA, ACK, DENIED</a:t>
+              <a:t>    • 协议类型：WHOHAS, IHAVE, GET, DATA, ACK, DENIED</a:t>
             </a:r>
           </a:p>
           <a:p>
@@ -5284,7 +5321,7 @@
               </a:defRPr>
             </a:pPr>
             <a:r>
-              <a:t>    • Header: Type(1B) + HLen(1B) + PLen(2B) + Seq(4B) + Ack(4B) + Flags(1B)</a:t>
+              <a:t>    • 包头格式：Type(1B) + HLen(1B) + PLen(2B) + Seq(4B) + Ack(4B) + Flags(1B)</a:t>
             </a:r>
           </a:p>
           <a:p>
@@ -5317,7 +5354,7 @@
               </a:defRPr>
             </a:pPr>
             <a:r>
-              <a:t>    • TransferSession: RDT + TCP congestion control</a:t>
+              <a:t>    • TransferSession：单个chunk传输 + TCP拥塞控制</a:t>
             </a:r>
           </a:p>
           <a:p>
@@ -5329,7 +5366,7 @@
               </a:defRPr>
             </a:pPr>
             <a:r>
-              <a:t>    • PeerState: Global peer state management</a:t>
+              <a:t>    • PeerState：Peer全局状态管理</a:t>
             </a:r>
           </a:p>
           <a:p>
@@ -5362,7 +5399,7 @@
               </a:defRPr>
             </a:pPr>
             <a:r>
-              <a:t>    • DownloadManager: Multi-chunk orchestration</a:t>
+              <a:t>    • DownloadManager：多chunk下载调度</a:t>
             </a:r>
           </a:p>
           <a:p>
@@ -5374,7 +5411,7 @@
               </a:defRPr>
             </a:pPr>
             <a:r>
-              <a:t>    • Event loop with select()</a:t>
+              <a:t>    • 事件循环：select() 监听socket + stdin</a:t>
             </a:r>
           </a:p>
         </p:txBody>
@@ -5470,7 +5507,7 @@
               </a:defRPr>
             </a:pPr>
             <a:r>
-              <a:t>Protocol Flow</a:t>
+              <a:t>协议流程</a:t>
             </a:r>
           </a:p>
         </p:txBody>
@@ -5505,7 +5542,7 @@
               </a:defRPr>
             </a:pPr>
             <a:r>
-              <a:t>📡 Chunk Discovery:</a:t>
+              <a:t>📡 Chunk 发现阶段：</a:t>
             </a:r>
           </a:p>
           <a:p>
@@ -5517,7 +5554,7 @@
               </a:defRPr>
             </a:pPr>
             <a:r>
-              <a:t>    1. Sender → Peers: WHOHAS(chunk_hashes)</a:t>
+              <a:t>    1. 发送方 → 所有Peer：WHOHAS(chunk哈希列表)</a:t>
             </a:r>
           </a:p>
           <a:p>
@@ -5529,7 +5566,7 @@
               </a:defRPr>
             </a:pPr>
             <a:r>
-              <a:t>    2. Peers → Sender: IHAVE(available_chunks)</a:t>
+              <a:t>    2. Peer → 发送方：IHAVE(可用chunk列表)</a:t>
             </a:r>
           </a:p>
           <a:p>
@@ -5550,7 +5587,7 @@
               </a:defRPr>
             </a:pPr>
             <a:r>
-              <a:t>📦 Data Transfer:</a:t>
+              <a:t>📦 数据传输阶段：</a:t>
             </a:r>
           </a:p>
           <a:p>
@@ -5562,7 +5599,7 @@
               </a:defRPr>
             </a:pPr>
             <a:r>
-              <a:t>    3. Sender → Peer: GET(chunk_hash)</a:t>
+              <a:t>    3. 发送方 → 目标Peer：GET(chunk哈希)</a:t>
             </a:r>
           </a:p>
           <a:p>
@@ -5574,7 +5611,7 @@
               </a:defRPr>
             </a:pPr>
             <a:r>
-              <a:t>    4. Peer → Sender: DATA(seq, data, is_last)</a:t>
+              <a:t>    4. Peer → 发送方：DATA(序列号, 数据, 是否最后一个)</a:t>
             </a:r>
           </a:p>
           <a:p>
@@ -5586,7 +5623,7 @@
               </a:defRPr>
             </a:pPr>
             <a:r>
-              <a:t>    5. Sender → Peer: ACK(seq)</a:t>
+              <a:t>    5. 发送方 → Peer：ACK(序列号)</a:t>
             </a:r>
           </a:p>
           <a:p>
@@ -5607,7 +5644,7 @@
               </a:defRPr>
             </a:pPr>
             <a:r>
-              <a:t>✅ Completion: Verify SHA1 hash → Save file</a:t>
+              <a:t>✅ 完成：验证 SHA1 哈希 → 保存文件</a:t>
             </a:r>
           </a:p>
         </p:txBody>
@@ -5703,7 +5740,7 @@
               </a:defRPr>
             </a:pPr>
             <a:r>
-              <a:t>TCP Reno Congestion Control</a:t>
+              <a:t>TCP Reno 拥塞控制</a:t>
             </a:r>
           </a:p>
         </p:txBody>
@@ -5738,7 +5775,7 @@
               </a:defRPr>
             </a:pPr>
             <a:r>
-              <a:t>🔄 Three States:</a:t>
+              <a:t>🔄 三个状态：</a:t>
             </a:r>
           </a:p>
           <a:p>
@@ -5750,7 +5787,7 @@
               </a:defRPr>
             </a:pPr>
             <a:r>
-              <a:t>    • slow_start: cwnd doubles each RTT</a:t>
+              <a:t>    • slow_start（慢启动）：cwnd 每个RTT翻倍</a:t>
             </a:r>
           </a:p>
           <a:p>
@@ -5762,7 +5799,7 @@
               </a:defRPr>
             </a:pPr>
             <a:r>
-              <a:t>    • congestion_avoidance: cwnd += 1/cwnd per ACK (AIMD)</a:t>
+              <a:t>    • congestion_avoidance（拥塞避免）：cwnd += 1/cwnd（AIMD）</a:t>
             </a:r>
           </a:p>
           <a:p>
@@ -5774,7 +5811,7 @@
               </a:defRPr>
             </a:pPr>
             <a:r>
-              <a:t>    • fast_recovery: 3 duplicate ACKs trigger</a:t>
+              <a:t>    • fast_recovery（快速恢复）：3个重复ACK触发</a:t>
             </a:r>
           </a:p>
           <a:p>
@@ -5795,7 +5832,7 @@
               </a:defRPr>
             </a:pPr>
             <a:r>
-              <a:t>⚙️ Parameters:</a:t>
+              <a:t>⚙️ 关键参数：</a:t>
             </a:r>
           </a:p>
           <a:p>
@@ -5807,7 +5844,7 @@
               </a:defRPr>
             </a:pPr>
             <a:r>
-              <a:t>    • cwnd: Congestion Window (initial = 1)</a:t>
+              <a:t>    • cwnd（拥塞窗口）：初始值 = 1</a:t>
             </a:r>
           </a:p>
           <a:p>
@@ -5819,7 +5856,7 @@
               </a:defRPr>
             </a:pPr>
             <a:r>
-              <a:t>    • ssthresh: Slow Start Threshold (initial = 64)</a:t>
+              <a:t>    • ssthresh（慢启动阈值）：初始值 = 64</a:t>
             </a:r>
           </a:p>
           <a:p>
@@ -5840,7 +5877,7 @@
               </a:defRPr>
             </a:pPr>
             <a:r>
-              <a:t>⏱️ Timeout = EstimatedRTT + 4 × DevRTT</a:t>
+              <a:t>⏱️ 超时时间 = EstimatedRTT + 4 × DevRTT</a:t>
             </a:r>
           </a:p>
         </p:txBody>
@@ -5936,7 +5973,7 @@
               </a:defRPr>
             </a:pPr>
             <a:r>
-              <a:t>Congestion Control - ACK Handling</a:t>
+              <a:t>拥塞控制 - ACK处理</a:t>
             </a:r>
           </a:p>
         </p:txBody>
@@ -6028,7 +6065,7 @@
               </a:defRPr>
             </a:pPr>
             <a:r>
-              <a:t>    if ack_seq in self.acked_packets:  # Duplicate ACK</a:t>
+              <a:t>    if ack_seq in self.acked_packets:  # 重复ACK</a:t>
             </a:r>
           </a:p>
           <a:p>
@@ -6067,7 +6104,7 @@
               </a:defRPr>
             </a:pPr>
             <a:r>
-              <a:t>            self._enter_fast_recovery()</a:t>
+              <a:t>            self._enter_fast_recovery()  # 快速重传</a:t>
             </a:r>
           </a:p>
           <a:p>
@@ -6080,7 +6117,7 @@
               </a:defRPr>
             </a:pPr>
             <a:r>
-              <a:t>    else:  # New ACK</a:t>
+              <a:t>    else:  # 新ACK</a:t>
             </a:r>
           </a:p>
           <a:p>
@@ -6184,7 +6221,7 @@
               </a:defRPr>
             </a:pPr>
             <a:r>
-              <a:t>            self.cwnd = self.ssthresh</a:t>
+              <a:t>            self.cwnd = self.ssthresh  # 退出快速恢复</a:t>
             </a:r>
           </a:p>
           <a:p>
@@ -6293,7 +6330,7 @@
               </a:defRPr>
             </a:pPr>
             <a:r>
-              <a:t>Fast Recovery &amp; Timeout</a:t>
+              <a:t>快速恢复与超时处理</a:t>
             </a:r>
           </a:p>
         </p:txBody>
@@ -6372,7 +6409,7 @@
               </a:defRPr>
             </a:pPr>
             <a:r>
-              <a:t>def _enter_fast_recovery(self):</a:t>
+              <a:t>def _enter_fast_recovery(self):  # 进入快速恢复</a:t>
             </a:r>
           </a:p>
           <a:p>
@@ -6385,6 +6422,68 @@
               </a:defRPr>
             </a:pPr>
             <a:r>
+              <a:t>    self.ssthresh = max(self.cwnd / 2, 2)  # 阈值减半</a:t>
+            </a:r>
+          </a:p>
+          <a:p>
+            <a:pPr>
+              <a:defRPr sz="1400">
+                <a:solidFill>
+                  <a:srgbClr val="ABB2BF"/>
+                </a:solidFill>
+                <a:latin typeface="Consolas"/>
+              </a:defRPr>
+            </a:pPr>
+            <a:r>
+              <a:t>    self.cwnd = self.ssthresh + 3          # 窗口膨胀</a:t>
+            </a:r>
+          </a:p>
+          <a:p>
+            <a:pPr>
+              <a:defRPr sz="1400">
+                <a:solidFill>
+                  <a:srgbClr val="ABB2BF"/>
+                </a:solidFill>
+                <a:latin typeface="Consolas"/>
+              </a:defRPr>
+            </a:pPr>
+            <a:r>
+              <a:t>    self.state = 'fast_recovery'</a:t>
+            </a:r>
+          </a:p>
+          <a:p>
+            <a:pPr>
+              <a:defRPr sz="1400">
+                <a:solidFill>
+                  <a:srgbClr val="ABB2BF"/>
+                </a:solidFill>
+                <a:latin typeface="Consolas"/>
+              </a:defRPr>
+            </a:pPr>
+          </a:p>
+          <a:p>
+            <a:pPr>
+              <a:defRPr sz="1400">
+                <a:solidFill>
+                  <a:srgbClr val="ABB2BF"/>
+                </a:solidFill>
+                <a:latin typeface="Consolas"/>
+              </a:defRPr>
+            </a:pPr>
+            <a:r>
+              <a:t>def _handle_timeout(self):  # 超时处理</a:t>
+            </a:r>
+          </a:p>
+          <a:p>
+            <a:pPr>
+              <a:defRPr sz="1400">
+                <a:solidFill>
+                  <a:srgbClr val="ABB2BF"/>
+                </a:solidFill>
+                <a:latin typeface="Consolas"/>
+              </a:defRPr>
+            </a:pPr>
+            <a:r>
               <a:t>    self.ssthresh = max(self.cwnd / 2, 2)</a:t>
             </a:r>
           </a:p>
@@ -6398,7 +6497,7 @@
               </a:defRPr>
             </a:pPr>
             <a:r>
-              <a:t>    self.cwnd = self.ssthresh + 3</a:t>
+              <a:t>    self.cwnd = 1                          # 重置为1</a:t>
             </a:r>
           </a:p>
           <a:p>
@@ -6411,7 +6510,7 @@
               </a:defRPr>
             </a:pPr>
             <a:r>
-              <a:t>    self.state = 'fast_recovery'</a:t>
+              <a:t>    self.state = 'slow_start'              # 回到慢启动</a:t>
             </a:r>
           </a:p>
           <a:p>
@@ -6423,6 +6522,9 @@
                 <a:latin typeface="Consolas"/>
               </a:defRPr>
             </a:pPr>
+            <a:r>
+              <a:t>    self.in_flight = 0</a:t>
+            </a:r>
           </a:p>
           <a:p>
             <a:pPr>
@@ -6433,9 +6535,6 @@
                 <a:latin typeface="Consolas"/>
               </a:defRPr>
             </a:pPr>
-            <a:r>
-              <a:t>def _handle_timeout(self):</a:t>
-            </a:r>
           </a:p>
           <a:p>
             <a:pPr>
@@ -6447,69 +6546,7 @@
               </a:defRPr>
             </a:pPr>
             <a:r>
-              <a:t>    self.ssthresh = max(self.cwnd / 2, 2)</a:t>
-            </a:r>
-          </a:p>
-          <a:p>
-            <a:pPr>
-              <a:defRPr sz="1400">
-                <a:solidFill>
-                  <a:srgbClr val="ABB2BF"/>
-                </a:solidFill>
-                <a:latin typeface="Consolas"/>
-              </a:defRPr>
-            </a:pPr>
-            <a:r>
-              <a:t>    self.cwnd = 1</a:t>
-            </a:r>
-          </a:p>
-          <a:p>
-            <a:pPr>
-              <a:defRPr sz="1400">
-                <a:solidFill>
-                  <a:srgbClr val="ABB2BF"/>
-                </a:solidFill>
-                <a:latin typeface="Consolas"/>
-              </a:defRPr>
-            </a:pPr>
-            <a:r>
-              <a:t>    self.state = 'slow_start'</a:t>
-            </a:r>
-          </a:p>
-          <a:p>
-            <a:pPr>
-              <a:defRPr sz="1400">
-                <a:solidFill>
-                  <a:srgbClr val="ABB2BF"/>
-                </a:solidFill>
-                <a:latin typeface="Consolas"/>
-              </a:defRPr>
-            </a:pPr>
-            <a:r>
-              <a:t>    self.in_flight = 0</a:t>
-            </a:r>
-          </a:p>
-          <a:p>
-            <a:pPr>
-              <a:defRPr sz="1400">
-                <a:solidFill>
-                  <a:srgbClr val="ABB2BF"/>
-                </a:solidFill>
-                <a:latin typeface="Consolas"/>
-              </a:defRPr>
-            </a:pPr>
-          </a:p>
-          <a:p>
-            <a:pPr>
-              <a:defRPr sz="1400">
-                <a:solidFill>
-                  <a:srgbClr val="ABB2BF"/>
-                </a:solidFill>
-                <a:latin typeface="Consolas"/>
-              </a:defRPr>
-            </a:pPr>
-            <a:r>
-              <a:t># TCP Reno: Fast Recovery avoids slow start on 3 dup ACKs</a:t>
+              <a:t># TCP Reno: 3个重复ACK触发快速恢复，避免回到慢启动</a:t>
             </a:r>
           </a:p>
         </p:txBody>
@@ -6605,7 +6642,7 @@
               </a:defRPr>
             </a:pPr>
             <a:r>
-              <a:t>RTT Estimation (RFC 6298)</a:t>
+              <a:t>RTT估计 (RFC 6298)</a:t>
             </a:r>
           </a:p>
         </p:txBody>
@@ -6720,7 +6757,7 @@
               </a:defRPr>
             </a:pPr>
             <a:r>
-              <a:t>    if first_sample:</a:t>
+              <a:t>    if first_sample:  # 首次测量</a:t>
             </a:r>
           </a:p>
           <a:p>
@@ -6759,7 +6796,7 @@
               </a:defRPr>
             </a:pPr>
             <a:r>
-              <a:t>    else:</a:t>
+              <a:t>    else:  # EWMA更新</a:t>
             </a:r>
           </a:p>
           <a:p>
@@ -6831,7 +6868,7 @@
               </a:defRPr>
             </a:pPr>
             <a:r>
-              <a:t># Only non-retransmitted packets used for RTT</a:t>
+              <a:t># 注意：重传的包不用于RTT估计</a:t>
             </a:r>
           </a:p>
         </p:txBody>
@@ -6927,7 +6964,7 @@
               </a:defRPr>
             </a:pPr>
             <a:r>
-              <a:t>Congestion Control Visualization</a:t>
+              <a:t>拥塞控制可视化</a:t>
             </a:r>
           </a:p>
         </p:txBody>
@@ -7007,7 +7044,7 @@
               </a:defRPr>
             </a:pPr>
             <a:r>
-              <a:t>📊 INSERT CWND PLOT HERE</a:t>
+              <a:t>📊 在此处插入 CWND 变化曲线图</a:t>
             </a:r>
           </a:p>
         </p:txBody>
@@ -7042,7 +7079,7 @@
               </a:defRPr>
             </a:pPr>
             <a:r>
-              <a:t>💡 Record cwnd values during transfer and plot</a:t>
+              <a:t>💡 记录传输过程中的cwnd值并绘图</a:t>
             </a:r>
           </a:p>
           <a:p>
@@ -7054,7 +7091,7 @@
               </a:defRPr>
             </a:pPr>
             <a:r>
-              <a:t>💡 Show: Slow Start → Congestion Avoidance → Fast Recovery</a:t>
+              <a:t>💡 应展示：慢启动 → 拥塞避免 → 快速恢复 的状态转换</a:t>
             </a:r>
           </a:p>
           <a:p>
@@ -7066,7 +7103,7 @@
               </a:defRPr>
             </a:pPr>
             <a:r>
-              <a:t>💡 Label state transitions on the plot</a:t>
+              <a:t>💡 在图中标注各状态转换点</a:t>
             </a:r>
           </a:p>
         </p:txBody>

</xml_diff>